<commit_message>
Keep gradient artwork flat across Office renderers
</commit_message>
<xml_diff>
--- a/slides/planb-starter-dark.pptx
+++ b/slides/planb-starter-dark.pptx
@@ -1146,7 +1146,7 @@
           <a:lstStyle/>
           <a:p>
             <a:r>
-              <a:t>CHART. The starter contains an editable native PowerPoint chart with an embedded Excel workbook. All values are synthetic. Use Edit Data to replace them. Give units, source, date and uncertainty. Use navy for structure, blue for context and gold for one emphasis.</a:t>
+              <a:t>CHART. The starter contains an editable native PowerPoint chart with an embedded Excel workbook. All values are synthetic. Use Edit Data to replace them. Give units, source, date and uncertainty. Preserve the selected light or dark edition colors and keep all labels readable.</a:t>
             </a:r>
           </a:p>
         </p:txBody>
@@ -1216,7 +1216,7 @@
           <a:lstStyle/>
           <a:p>
             <a:r>
-              <a:t>TABLE. Native editable table in the starter. Keep to 3–4 columns and 3–5 rows. Replace bracketed fields. Do not use a screenshot of a spreadsheet. Keep text at least 20pt. Use a navy header and alternating quiet grounds.</a:t>
+              <a:t>TABLE. Native editable table in the starter. Keep to 3–4 columns and 3–5 rows. Replace bracketed fields. Do not use a screenshot of a spreadsheet. Keep text at least 20pt. Preserve the selected edition header and alternating quiet grounds.</a:t>
             </a:r>
           </a:p>
         </p:txBody>
@@ -1442,20 +1442,6 @@
           </a:ln>
           <a:effectLst/>
         </p:spPr>
-        <p:style>
-          <a:lnRef idx="1">
-            <a:schemeClr val="accent1"/>
-          </a:lnRef>
-          <a:fillRef idx="3">
-            <a:schemeClr val="accent1"/>
-          </a:fillRef>
-          <a:effectRef idx="2">
-            <a:schemeClr val="accent1"/>
-          </a:effectRef>
-          <a:fontRef idx="minor">
-            <a:schemeClr val="lt1"/>
-          </a:fontRef>
-        </p:style>
         <p:txBody>
           <a:bodyPr rtlCol="0" anchor="ctr"/>
           <a:lstStyle/>
@@ -1747,20 +1733,6 @@
           </a:ln>
           <a:effectLst/>
         </p:spPr>
-        <p:style>
-          <a:lnRef idx="1">
-            <a:schemeClr val="accent1"/>
-          </a:lnRef>
-          <a:fillRef idx="3">
-            <a:schemeClr val="accent1"/>
-          </a:fillRef>
-          <a:effectRef idx="2">
-            <a:schemeClr val="accent1"/>
-          </a:effectRef>
-          <a:fontRef idx="minor">
-            <a:schemeClr val="lt1"/>
-          </a:fontRef>
-        </p:style>
         <p:txBody>
           <a:bodyPr rtlCol="0" anchor="ctr"/>
           <a:lstStyle/>
@@ -1936,20 +1908,6 @@
           </a:ln>
           <a:effectLst/>
         </p:spPr>
-        <p:style>
-          <a:lnRef idx="1">
-            <a:schemeClr val="accent1"/>
-          </a:lnRef>
-          <a:fillRef idx="3">
-            <a:schemeClr val="accent1"/>
-          </a:fillRef>
-          <a:effectRef idx="2">
-            <a:schemeClr val="accent1"/>
-          </a:effectRef>
-          <a:fontRef idx="minor">
-            <a:schemeClr val="lt1"/>
-          </a:fontRef>
-        </p:style>
         <p:txBody>
           <a:bodyPr rtlCol="0" anchor="ctr"/>
           <a:lstStyle/>
@@ -2032,20 +1990,6 @@
           </a:ln>
           <a:effectLst/>
         </p:spPr>
-        <p:style>
-          <a:lnRef idx="1">
-            <a:schemeClr val="accent1"/>
-          </a:lnRef>
-          <a:fillRef idx="3">
-            <a:schemeClr val="accent1"/>
-          </a:fillRef>
-          <a:effectRef idx="2">
-            <a:schemeClr val="accent1"/>
-          </a:effectRef>
-          <a:fontRef idx="minor">
-            <a:schemeClr val="lt1"/>
-          </a:fontRef>
-        </p:style>
         <p:txBody>
           <a:bodyPr rtlCol="0" anchor="ctr"/>
           <a:lstStyle/>
@@ -2382,20 +2326,6 @@
           </a:ln>
           <a:effectLst/>
         </p:spPr>
-        <p:style>
-          <a:lnRef idx="1">
-            <a:schemeClr val="accent1"/>
-          </a:lnRef>
-          <a:fillRef idx="3">
-            <a:schemeClr val="accent1"/>
-          </a:fillRef>
-          <a:effectRef idx="2">
-            <a:schemeClr val="accent1"/>
-          </a:effectRef>
-          <a:fontRef idx="minor">
-            <a:schemeClr val="lt1"/>
-          </a:fontRef>
-        </p:style>
         <p:txBody>
           <a:bodyPr rtlCol="0" anchor="ctr"/>
           <a:lstStyle/>
@@ -2426,20 +2356,6 @@
           </a:ln>
           <a:effectLst/>
         </p:spPr>
-        <p:style>
-          <a:lnRef idx="1">
-            <a:schemeClr val="accent1"/>
-          </a:lnRef>
-          <a:fillRef idx="3">
-            <a:schemeClr val="accent1"/>
-          </a:fillRef>
-          <a:effectRef idx="2">
-            <a:schemeClr val="accent1"/>
-          </a:effectRef>
-          <a:fontRef idx="minor">
-            <a:schemeClr val="lt1"/>
-          </a:fontRef>
-        </p:style>
         <p:txBody>
           <a:bodyPr rtlCol="0" anchor="ctr"/>
           <a:lstStyle/>
@@ -2470,20 +2386,6 @@
           </a:ln>
           <a:effectLst/>
         </p:spPr>
-        <p:style>
-          <a:lnRef idx="1">
-            <a:schemeClr val="accent1"/>
-          </a:lnRef>
-          <a:fillRef idx="3">
-            <a:schemeClr val="accent1"/>
-          </a:fillRef>
-          <a:effectRef idx="2">
-            <a:schemeClr val="accent1"/>
-          </a:effectRef>
-          <a:fontRef idx="minor">
-            <a:schemeClr val="lt1"/>
-          </a:fontRef>
-        </p:style>
         <p:txBody>
           <a:bodyPr rtlCol="0" anchor="ctr"/>
           <a:lstStyle/>
@@ -2514,20 +2416,6 @@
           </a:ln>
           <a:effectLst/>
         </p:spPr>
-        <p:style>
-          <a:lnRef idx="1">
-            <a:schemeClr val="accent1"/>
-          </a:lnRef>
-          <a:fillRef idx="3">
-            <a:schemeClr val="accent1"/>
-          </a:fillRef>
-          <a:effectRef idx="2">
-            <a:schemeClr val="accent1"/>
-          </a:effectRef>
-          <a:fontRef idx="minor">
-            <a:schemeClr val="lt1"/>
-          </a:fontRef>
-        </p:style>
         <p:txBody>
           <a:bodyPr rtlCol="0" anchor="ctr"/>
           <a:lstStyle/>
@@ -2653,20 +2541,6 @@
           </a:ln>
           <a:effectLst/>
         </p:spPr>
-        <p:style>
-          <a:lnRef idx="1">
-            <a:schemeClr val="accent1"/>
-          </a:lnRef>
-          <a:fillRef idx="3">
-            <a:schemeClr val="accent1"/>
-          </a:fillRef>
-          <a:effectRef idx="2">
-            <a:schemeClr val="accent1"/>
-          </a:effectRef>
-          <a:fontRef idx="minor">
-            <a:schemeClr val="lt1"/>
-          </a:fontRef>
-        </p:style>
         <p:txBody>
           <a:bodyPr rtlCol="0" anchor="ctr"/>
           <a:lstStyle/>
@@ -2749,20 +2623,6 @@
           </a:ln>
           <a:effectLst/>
         </p:spPr>
-        <p:style>
-          <a:lnRef idx="1">
-            <a:schemeClr val="accent1"/>
-          </a:lnRef>
-          <a:fillRef idx="3">
-            <a:schemeClr val="accent1"/>
-          </a:fillRef>
-          <a:effectRef idx="2">
-            <a:schemeClr val="accent1"/>
-          </a:effectRef>
-          <a:fontRef idx="minor">
-            <a:schemeClr val="lt1"/>
-          </a:fontRef>
-        </p:style>
         <p:txBody>
           <a:bodyPr rtlCol="0" anchor="ctr"/>
           <a:lstStyle/>
@@ -2983,20 +2843,6 @@
           </a:ln>
           <a:effectLst/>
         </p:spPr>
-        <p:style>
-          <a:lnRef idx="1">
-            <a:schemeClr val="accent1"/>
-          </a:lnRef>
-          <a:fillRef idx="3">
-            <a:schemeClr val="accent1"/>
-          </a:fillRef>
-          <a:effectRef idx="2">
-            <a:schemeClr val="accent1"/>
-          </a:effectRef>
-          <a:fontRef idx="minor">
-            <a:schemeClr val="lt1"/>
-          </a:fontRef>
-        </p:style>
         <p:txBody>
           <a:bodyPr rtlCol="0" anchor="ctr"/>
           <a:lstStyle/>
@@ -3079,20 +2925,6 @@
           </a:ln>
           <a:effectLst/>
         </p:spPr>
-        <p:style>
-          <a:lnRef idx="1">
-            <a:schemeClr val="accent1"/>
-          </a:lnRef>
-          <a:fillRef idx="3">
-            <a:schemeClr val="accent1"/>
-          </a:fillRef>
-          <a:effectRef idx="2">
-            <a:schemeClr val="accent1"/>
-          </a:effectRef>
-          <a:fontRef idx="minor">
-            <a:schemeClr val="lt1"/>
-          </a:fontRef>
-        </p:style>
         <p:txBody>
           <a:bodyPr rtlCol="0" anchor="ctr"/>
           <a:lstStyle/>
@@ -3436,20 +3268,6 @@
           </a:ln>
           <a:effectLst/>
         </p:spPr>
-        <p:style>
-          <a:lnRef idx="1">
-            <a:schemeClr val="accent1"/>
-          </a:lnRef>
-          <a:fillRef idx="3">
-            <a:schemeClr val="accent1"/>
-          </a:fillRef>
-          <a:effectRef idx="2">
-            <a:schemeClr val="accent1"/>
-          </a:effectRef>
-          <a:fontRef idx="minor">
-            <a:schemeClr val="lt1"/>
-          </a:fontRef>
-        </p:style>
         <p:txBody>
           <a:bodyPr rtlCol="0" anchor="ctr"/>
           <a:lstStyle/>
@@ -3791,20 +3609,6 @@
           </a:ln>
           <a:effectLst/>
         </p:spPr>
-        <p:style>
-          <a:lnRef idx="1">
-            <a:schemeClr val="accent1"/>
-          </a:lnRef>
-          <a:fillRef idx="3">
-            <a:schemeClr val="accent1"/>
-          </a:fillRef>
-          <a:effectRef idx="2">
-            <a:schemeClr val="accent1"/>
-          </a:effectRef>
-          <a:fontRef idx="minor">
-            <a:schemeClr val="lt1"/>
-          </a:fontRef>
-        </p:style>
         <p:txBody>
           <a:bodyPr rtlCol="0" anchor="ctr"/>
           <a:lstStyle/>
@@ -3887,20 +3691,6 @@
           </a:ln>
           <a:effectLst/>
         </p:spPr>
-        <p:style>
-          <a:lnRef idx="1">
-            <a:schemeClr val="accent1"/>
-          </a:lnRef>
-          <a:fillRef idx="3">
-            <a:schemeClr val="accent1"/>
-          </a:fillRef>
-          <a:effectRef idx="2">
-            <a:schemeClr val="accent1"/>
-          </a:effectRef>
-          <a:fontRef idx="minor">
-            <a:schemeClr val="lt1"/>
-          </a:fontRef>
-        </p:style>
         <p:txBody>
           <a:bodyPr rtlCol="0" anchor="ctr"/>
           <a:lstStyle/>
@@ -4064,20 +3854,6 @@
           </a:ln>
           <a:effectLst/>
         </p:spPr>
-        <p:style>
-          <a:lnRef idx="1">
-            <a:schemeClr val="accent1"/>
-          </a:lnRef>
-          <a:fillRef idx="3">
-            <a:schemeClr val="accent1"/>
-          </a:fillRef>
-          <a:effectRef idx="2">
-            <a:schemeClr val="accent1"/>
-          </a:effectRef>
-          <a:fontRef idx="minor">
-            <a:schemeClr val="lt1"/>
-          </a:fontRef>
-        </p:style>
         <p:txBody>
           <a:bodyPr rtlCol="0" anchor="ctr"/>
           <a:lstStyle/>
@@ -4383,20 +4159,6 @@
           </a:ln>
           <a:effectLst/>
         </p:spPr>
-        <p:style>
-          <a:lnRef idx="1">
-            <a:schemeClr val="accent1"/>
-          </a:lnRef>
-          <a:fillRef idx="3">
-            <a:schemeClr val="accent1"/>
-          </a:fillRef>
-          <a:effectRef idx="2">
-            <a:schemeClr val="accent1"/>
-          </a:effectRef>
-          <a:fontRef idx="minor">
-            <a:schemeClr val="lt1"/>
-          </a:fontRef>
-        </p:style>
         <p:txBody>
           <a:bodyPr rtlCol="0" anchor="ctr"/>
           <a:lstStyle/>
@@ -4835,20 +4597,6 @@
           </a:ln>
           <a:effectLst/>
         </p:spPr>
-        <p:style>
-          <a:lnRef idx="1">
-            <a:schemeClr val="accent1"/>
-          </a:lnRef>
-          <a:fillRef idx="3">
-            <a:schemeClr val="accent1"/>
-          </a:fillRef>
-          <a:effectRef idx="2">
-            <a:schemeClr val="accent1"/>
-          </a:effectRef>
-          <a:fontRef idx="minor">
-            <a:schemeClr val="lt1"/>
-          </a:fontRef>
-        </p:style>
         <p:txBody>
           <a:bodyPr rtlCol="0" anchor="ctr"/>
           <a:lstStyle/>
@@ -5197,20 +4945,6 @@
           </a:ln>
           <a:effectLst/>
         </p:spPr>
-        <p:style>
-          <a:lnRef idx="1">
-            <a:schemeClr val="accent1"/>
-          </a:lnRef>
-          <a:fillRef idx="3">
-            <a:schemeClr val="accent1"/>
-          </a:fillRef>
-          <a:effectRef idx="2">
-            <a:schemeClr val="accent1"/>
-          </a:effectRef>
-          <a:fontRef idx="minor">
-            <a:schemeClr val="lt1"/>
-          </a:fontRef>
-        </p:style>
         <p:txBody>
           <a:bodyPr rtlCol="0" anchor="ctr"/>
           <a:lstStyle/>
@@ -5471,20 +5205,6 @@
           </a:ln>
           <a:effectLst/>
         </p:spPr>
-        <p:style>
-          <a:lnRef idx="1">
-            <a:schemeClr val="accent1"/>
-          </a:lnRef>
-          <a:fillRef idx="3">
-            <a:schemeClr val="accent1"/>
-          </a:fillRef>
-          <a:effectRef idx="2">
-            <a:schemeClr val="accent1"/>
-          </a:effectRef>
-          <a:fontRef idx="minor">
-            <a:schemeClr val="lt1"/>
-          </a:fontRef>
-        </p:style>
         <p:txBody>
           <a:bodyPr rtlCol="0" anchor="ctr"/>
           <a:lstStyle/>
@@ -5567,20 +5287,6 @@
           </a:ln>
           <a:effectLst/>
         </p:spPr>
-        <p:style>
-          <a:lnRef idx="1">
-            <a:schemeClr val="accent1"/>
-          </a:lnRef>
-          <a:fillRef idx="3">
-            <a:schemeClr val="accent1"/>
-          </a:fillRef>
-          <a:effectRef idx="2">
-            <a:schemeClr val="accent1"/>
-          </a:effectRef>
-          <a:fontRef idx="minor">
-            <a:schemeClr val="lt1"/>
-          </a:fontRef>
-        </p:style>
         <p:txBody>
           <a:bodyPr rtlCol="0" anchor="ctr"/>
           <a:lstStyle/>

</xml_diff>

<commit_message>
Make cover artwork selectable and add vector logo libraries with shared master footer
</commit_message>
<xml_diff>
--- a/slides/planb-starter-dark.pptx
+++ b/slides/planb-starter-dark.pptx
@@ -15,6 +15,9 @@
     <p:sldId id="263" r:id="rId15"/>
     <p:sldId id="264" r:id="rId16"/>
     <p:sldId id="265" r:id="rId17"/>
+    <p:sldId id="266" r:id="rId18"/>
+    <p:sldId id="267" r:id="rId19"/>
+    <p:sldId id="268" r:id="rId20"/>
   </p:sldIdLst>
   <p:sldSz cx="12191999" cy="6858000" type="screen4x3"/>
   <p:notesSz cx="6858000" cy="9144000"/>
@@ -726,7 +729,7 @@
           <a:lstStyle/>
           <a:p>
             <a:r>
-              <a:t>COVER. Replace bracketed text. Aim for a title under 8 words. Keep the inherited mark intact. This template uses the existing Lugano Plan B identity, not a newly designed Foundation logo. Install bundled Inter fonts before editing. Choose Home &gt; New Slide for Plan B layouts.</a:t>
+              <a:t>COVER. Replace bracketed text. Aim for a title under 8 words. Keep the inherited mark intact. This template uses the existing Lugano Plan B identity, not a newly designed Foundation logo. Install bundled Inter fonts before editing. The right-side panel, SVG logo, values text and top gradient are separate selectable slide objects. Duplicate this cover to preserve them; New Slide uses the content layout only. Swap logos by copying from the three logo-library slides. Edit both shared footer text boxes once on View &gt; Slide Master &gt; the top parent master, then Close Master View.</a:t>
             </a:r>
           </a:p>
         </p:txBody>
@@ -797,6 +800,216 @@
           <a:p>
             <a:r>
               <a:t>GUIDE. This deck is an editable starter, not a finished presentation. Ten Plan B layouts plus a branded blank are supplied. Speaker notes describe usage. Reuse the POTX in PowerPoint to create a new document. Keynote/LibreOffice may vary in rendering; check after import.</a:t>
+            </a:r>
+          </a:p>
+        </p:txBody>
+      </p:sp>
+      <p:sp>
+        <p:nvSpPr>
+          <p:cNvPr id="4" name="Slide Number Placeholder 3"/>
+          <p:cNvSpPr>
+            <a:spLocks noGrp="1"/>
+          </p:cNvSpPr>
+          <p:nvPr>
+            <p:ph type="sldNum" idx="5" sz="quarter"/>
+          </p:nvPr>
+        </p:nvSpPr>
+        <p:spPr/>
+      </p:sp>
+    </p:spTree>
+  </p:cSld>
+  <p:clrMapOvr>
+    <a:masterClrMapping/>
+  </p:clrMapOvr>
+</p:notes>
+</file>
+
+<file path=ppt/notesSlides/notesSlide11.xml><?xml version="1.0" encoding="utf-8"?>
+<p:notes xmlns:a="http://schemas.openxmlformats.org/drawingml/2006/main" xmlns:p="http://schemas.openxmlformats.org/presentationml/2006/main" xmlns:r="http://schemas.openxmlformats.org/officeDocument/2006/relationships">
+  <p:cSld>
+    <p:spTree>
+      <p:nvGrpSpPr>
+        <p:cNvPr id="1" name=""/>
+        <p:cNvGrpSpPr/>
+        <p:nvPr/>
+      </p:nvGrpSpPr>
+      <p:grpSpPr>
+        <a:xfrm>
+          <a:off x="0" y="0"/>
+          <a:ext cx="0" cy="0"/>
+          <a:chOff x="0" y="0"/>
+          <a:chExt cx="0" cy="0"/>
+        </a:xfrm>
+      </p:grpSpPr>
+      <p:sp>
+        <p:nvSpPr>
+          <p:cNvPr id="2" name="Slide Image Placeholder 1"/>
+          <p:cNvSpPr>
+            <a:spLocks noGrp="1"/>
+          </p:cNvSpPr>
+          <p:nvPr>
+            <p:ph type="sldImg" idx="2"/>
+          </p:nvPr>
+        </p:nvSpPr>
+        <p:spPr/>
+      </p:sp>
+      <p:sp>
+        <p:nvSpPr>
+          <p:cNvPr id="3" name="Notes Placeholder 2"/>
+          <p:cNvSpPr>
+            <a:spLocks noGrp="1"/>
+          </p:cNvSpPr>
+          <p:nvPr>
+            <p:ph type="body" idx="3" sz="quarter"/>
+          </p:nvPr>
+        </p:nvSpPr>
+        <p:spPr/>
+        <p:txBody>
+          <a:bodyPr/>
+          <a:lstStyle/>
+          <a:p>
+            <a:r>
+              <a:t>LOGO LIBRARY. Each logo is an original embedded SVG with a PNG fallback for older viewers. Copy the logo itself, not the background rectangle. Keep original proportions and colors. Color and white logos need a dark ground; black needs a light ground. Delete this slide before presenting. Shared footer: View &gt; Slide Master &gt; top parent master.</a:t>
+            </a:r>
+          </a:p>
+        </p:txBody>
+      </p:sp>
+      <p:sp>
+        <p:nvSpPr>
+          <p:cNvPr id="4" name="Slide Number Placeholder 3"/>
+          <p:cNvSpPr>
+            <a:spLocks noGrp="1"/>
+          </p:cNvSpPr>
+          <p:nvPr>
+            <p:ph type="sldNum" idx="5" sz="quarter"/>
+          </p:nvPr>
+        </p:nvSpPr>
+        <p:spPr/>
+      </p:sp>
+    </p:spTree>
+  </p:cSld>
+  <p:clrMapOvr>
+    <a:masterClrMapping/>
+  </p:clrMapOvr>
+</p:notes>
+</file>
+
+<file path=ppt/notesSlides/notesSlide12.xml><?xml version="1.0" encoding="utf-8"?>
+<p:notes xmlns:a="http://schemas.openxmlformats.org/drawingml/2006/main" xmlns:p="http://schemas.openxmlformats.org/presentationml/2006/main" xmlns:r="http://schemas.openxmlformats.org/officeDocument/2006/relationships">
+  <p:cSld>
+    <p:spTree>
+      <p:nvGrpSpPr>
+        <p:cNvPr id="1" name=""/>
+        <p:cNvGrpSpPr/>
+        <p:nvPr/>
+      </p:nvGrpSpPr>
+      <p:grpSpPr>
+        <a:xfrm>
+          <a:off x="0" y="0"/>
+          <a:ext cx="0" cy="0"/>
+          <a:chOff x="0" y="0"/>
+          <a:chExt cx="0" cy="0"/>
+        </a:xfrm>
+      </p:grpSpPr>
+      <p:sp>
+        <p:nvSpPr>
+          <p:cNvPr id="2" name="Slide Image Placeholder 1"/>
+          <p:cNvSpPr>
+            <a:spLocks noGrp="1"/>
+          </p:cNvSpPr>
+          <p:nvPr>
+            <p:ph type="sldImg" idx="2"/>
+          </p:nvPr>
+        </p:nvSpPr>
+        <p:spPr/>
+      </p:sp>
+      <p:sp>
+        <p:nvSpPr>
+          <p:cNvPr id="3" name="Notes Placeholder 2"/>
+          <p:cNvSpPr>
+            <a:spLocks noGrp="1"/>
+          </p:cNvSpPr>
+          <p:nvPr>
+            <p:ph type="body" idx="3" sz="quarter"/>
+          </p:nvPr>
+        </p:nvSpPr>
+        <p:spPr/>
+        <p:txBody>
+          <a:bodyPr/>
+          <a:lstStyle/>
+          <a:p>
+            <a:r>
+              <a:t>LOGO LIBRARY. Each logo is an original embedded SVG with a PNG fallback for older viewers. Copy the logo itself, not the background rectangle. Keep original proportions and colors. Color and white logos need a dark ground; black needs a light ground. Delete this slide before presenting. Shared footer: View &gt; Slide Master &gt; top parent master.</a:t>
+            </a:r>
+          </a:p>
+        </p:txBody>
+      </p:sp>
+      <p:sp>
+        <p:nvSpPr>
+          <p:cNvPr id="4" name="Slide Number Placeholder 3"/>
+          <p:cNvSpPr>
+            <a:spLocks noGrp="1"/>
+          </p:cNvSpPr>
+          <p:nvPr>
+            <p:ph type="sldNum" idx="5" sz="quarter"/>
+          </p:nvPr>
+        </p:nvSpPr>
+        <p:spPr/>
+      </p:sp>
+    </p:spTree>
+  </p:cSld>
+  <p:clrMapOvr>
+    <a:masterClrMapping/>
+  </p:clrMapOvr>
+</p:notes>
+</file>
+
+<file path=ppt/notesSlides/notesSlide13.xml><?xml version="1.0" encoding="utf-8"?>
+<p:notes xmlns:a="http://schemas.openxmlformats.org/drawingml/2006/main" xmlns:p="http://schemas.openxmlformats.org/presentationml/2006/main" xmlns:r="http://schemas.openxmlformats.org/officeDocument/2006/relationships">
+  <p:cSld>
+    <p:spTree>
+      <p:nvGrpSpPr>
+        <p:cNvPr id="1" name=""/>
+        <p:cNvGrpSpPr/>
+        <p:nvPr/>
+      </p:nvGrpSpPr>
+      <p:grpSpPr>
+        <a:xfrm>
+          <a:off x="0" y="0"/>
+          <a:ext cx="0" cy="0"/>
+          <a:chOff x="0" y="0"/>
+          <a:chExt cx="0" cy="0"/>
+        </a:xfrm>
+      </p:grpSpPr>
+      <p:sp>
+        <p:nvSpPr>
+          <p:cNvPr id="2" name="Slide Image Placeholder 1"/>
+          <p:cNvSpPr>
+            <a:spLocks noGrp="1"/>
+          </p:cNvSpPr>
+          <p:nvPr>
+            <p:ph type="sldImg" idx="2"/>
+          </p:nvPr>
+        </p:nvSpPr>
+        <p:spPr/>
+      </p:sp>
+      <p:sp>
+        <p:nvSpPr>
+          <p:cNvPr id="3" name="Notes Placeholder 2"/>
+          <p:cNvSpPr>
+            <a:spLocks noGrp="1"/>
+          </p:cNvSpPr>
+          <p:nvPr>
+            <p:ph type="body" idx="3" sz="quarter"/>
+          </p:nvPr>
+        </p:nvSpPr>
+        <p:spPr/>
+        <p:txBody>
+          <a:bodyPr/>
+          <a:lstStyle/>
+          <a:p>
+            <a:r>
+              <a:t>LOGO LIBRARY. Each logo is an original embedded SVG with a PNG fallback for older viewers. Copy the logo itself, not the background rectangle. Keep original proportions and colors. Color and white logos need a dark ground; black needs a light ground. Delete this slide before presenting. Shared footer: View &gt; Slide Master &gt; top parent master.</a:t>
             </a:r>
           </a:p>
         </p:txBody>
@@ -1452,93 +1665,7 @@
       </p:sp>
       <p:sp>
         <p:nvSpPr>
-          <p:cNvPr id="3" name="Plan B Foundation"/>
-          <p:cNvSpPr txBox="1"/>
-          <p:nvPr/>
-        </p:nvSpPr>
-        <p:spPr>
-          <a:xfrm>
-            <a:off x="594360" y="6382512"/>
-            <a:ext cx="3657600" cy="228600"/>
-          </a:xfrm>
-          <a:prstGeom prst="rect">
-            <a:avLst/>
-          </a:prstGeom>
-          <a:noFill/>
-        </p:spPr>
-        <p:txBody>
-          <a:bodyPr wrap="square" lIns="0" rIns="0" tIns="0" bIns="0">
-            <a:spAutoFit/>
-          </a:bodyPr>
-          <a:lstStyle/>
-          <a:p>
-            <a:pPr algn="l" marL="0" indent="0">
-              <a:defRPr sz="1100" b="1">
-                <a:solidFill>
-                  <a:srgbClr val="FFFFFF"/>
-                </a:solidFill>
-                <a:latin typeface="Inter"/>
-              </a:defRPr>
-              <a:lnSpc>
-                <a:spcPct val="112000"/>
-              </a:lnSpc>
-              <a:spcAft>
-                <a:spcPts val="1200"/>
-              </a:spcAft>
-              <a:buNone/>
-            </a:pPr>
-            <a:r>
-              <a:t>Plan B Foundation</a:t>
-            </a:r>
-          </a:p>
-        </p:txBody>
-      </p:sp>
-      <p:sp>
-        <p:nvSpPr>
-          <p:cNvPr id="4" name="Civic Digital Commons"/>
-          <p:cNvSpPr txBox="1"/>
-          <p:nvPr/>
-        </p:nvSpPr>
-        <p:spPr>
-          <a:xfrm>
-            <a:off x="8595360" y="6382512"/>
-            <a:ext cx="2971800" cy="228600"/>
-          </a:xfrm>
-          <a:prstGeom prst="rect">
-            <a:avLst/>
-          </a:prstGeom>
-          <a:noFill/>
-        </p:spPr>
-        <p:txBody>
-          <a:bodyPr wrap="square" lIns="0" rIns="0" tIns="0" bIns="0">
-            <a:spAutoFit/>
-          </a:bodyPr>
-          <a:lstStyle/>
-          <a:p>
-            <a:pPr algn="l" marL="0" indent="0">
-              <a:defRPr sz="1100" b="0">
-                <a:solidFill>
-                  <a:srgbClr val="FFFFFF"/>
-                </a:solidFill>
-                <a:latin typeface="Inter"/>
-              </a:defRPr>
-              <a:lnSpc>
-                <a:spcPct val="112000"/>
-              </a:lnSpc>
-              <a:spcAft>
-                <a:spcPts val="1200"/>
-              </a:spcAft>
-              <a:buNone/>
-            </a:pPr>
-            <a:r>
-              <a:t>Civic Digital Commons</a:t>
-            </a:r>
-          </a:p>
-        </p:txBody>
-      </p:sp>
-      <p:sp>
-        <p:nvSpPr>
-          <p:cNvPr id="5" name="Placeholder 0"/>
+          <p:cNvPr id="3" name="Placeholder 0"/>
           <p:cNvSpPr txBox="1"/>
           <p:nvPr>
             <p:ph type="title" idx="0"/>
@@ -1603,7 +1730,7 @@
       </p:sp>
       <p:sp>
         <p:nvSpPr>
-          <p:cNvPr id="6" name="Placeholder 1"/>
+          <p:cNvPr id="4" name="Placeholder 1"/>
           <p:cNvSpPr txBox="1"/>
           <p:nvPr>
             <p:ph type="subTitle" idx="1"/>
@@ -1648,7 +1775,7 @@
       </p:sp>
       <p:sp>
         <p:nvSpPr>
-          <p:cNvPr id="7" name="Placeholder 2"/>
+          <p:cNvPr id="5" name="Placeholder 2"/>
           <p:cNvSpPr txBox="1"/>
           <p:nvPr>
             <p:ph type="body" idx="2"/>
@@ -1708,211 +1835,6 @@
             <a:r>
               <a:t>[Event · date]</a:t>
             </a:r>
-          </a:p>
-        </p:txBody>
-      </p:sp>
-      <p:sp>
-        <p:nvSpPr>
-          <p:cNvPr id="8" name="Rectangle 7"/>
-          <p:cNvSpPr/>
-          <p:nvPr/>
-        </p:nvSpPr>
-        <p:spPr>
-          <a:xfrm>
-            <a:off x="7818120" y="0"/>
-            <a:ext cx="4379976" cy="6080760"/>
-          </a:xfrm>
-          <a:prstGeom prst="rect">
-            <a:avLst/>
-          </a:prstGeom>
-          <a:solidFill>
-            <a:srgbClr val="211D1D"/>
-          </a:solidFill>
-          <a:ln>
-            <a:noFill/>
-          </a:ln>
-          <a:effectLst/>
-        </p:spPr>
-        <p:txBody>
-          <a:bodyPr rtlCol="0" anchor="ctr"/>
-          <a:lstStyle/>
-          <a:p>
-            <a:pPr algn="ctr"/>
-          </a:p>
-        </p:txBody>
-      </p:sp>
-      <p:pic>
-        <p:nvPicPr>
-          <p:cNvPr id="9" name="Original Lugano's Plan B mark" descr="Lugano's Plan B original logo; existing mark, not a new Foundation logo"/>
-          <p:cNvPicPr>
-            <a:picLocks noChangeAspect="1"/>
-          </p:cNvPicPr>
-          <p:nvPr/>
-        </p:nvPicPr>
-        <p:blipFill>
-          <a:blip r:embed="rId2">
-            <a:ext uri="{96DAC541-7B7A-43D3-8B79-37D633B846F1}">
-              <ns0:svgBlip xmlns:ns0="http://schemas.microsoft.com/office/drawing/2016/SVG/main" r:embed="rId3"/>
-            </a:ext>
-          </a:blip>
-          <a:stretch>
-            <a:fillRect/>
-          </a:stretch>
-        </p:blipFill>
-        <p:spPr>
-          <a:xfrm>
-            <a:off x="8302752" y="1325880"/>
-            <a:ext cx="3401568" cy="720671"/>
-          </a:xfrm>
-          <a:prstGeom prst="rect">
-            <a:avLst/>
-          </a:prstGeom>
-        </p:spPr>
-      </p:pic>
-      <p:sp>
-        <p:nvSpPr>
-          <p:cNvPr id="10" name="Open.&#10;Capable.&#10;Curious.&#10;Grounded."/>
-          <p:cNvSpPr txBox="1"/>
-          <p:nvPr/>
-        </p:nvSpPr>
-        <p:spPr>
-          <a:xfrm>
-            <a:off x="8302752" y="2788920"/>
-            <a:ext cx="3291840" cy="2103120"/>
-          </a:xfrm>
-          <a:prstGeom prst="rect">
-            <a:avLst/>
-          </a:prstGeom>
-          <a:noFill/>
-        </p:spPr>
-        <p:txBody>
-          <a:bodyPr wrap="square" lIns="0" rIns="0" tIns="0" bIns="0">
-            <a:spAutoFit/>
-          </a:bodyPr>
-          <a:lstStyle/>
-          <a:p>
-            <a:pPr algn="l" marL="0" indent="0">
-              <a:defRPr sz="2900" b="1">
-                <a:solidFill>
-                  <a:srgbClr val="FFFFFF"/>
-                </a:solidFill>
-                <a:latin typeface="Inter"/>
-              </a:defRPr>
-              <a:lnSpc>
-                <a:spcPct val="112000"/>
-              </a:lnSpc>
-              <a:spcAft>
-                <a:spcPts val="1200"/>
-              </a:spcAft>
-              <a:buNone/>
-            </a:pPr>
-            <a:r>
-              <a:t>Open.</a:t>
-            </a:r>
-          </a:p>
-          <a:p>
-            <a:pPr algn="l" marL="0" indent="0">
-              <a:defRPr sz="2900" b="1">
-                <a:solidFill>
-                  <a:srgbClr val="FFFFFF"/>
-                </a:solidFill>
-                <a:latin typeface="Inter"/>
-              </a:defRPr>
-              <a:lnSpc>
-                <a:spcPct val="112000"/>
-              </a:lnSpc>
-              <a:spcAft>
-                <a:spcPts val="1200"/>
-              </a:spcAft>
-              <a:buNone/>
-            </a:pPr>
-            <a:r>
-              <a:t>Capable.</a:t>
-            </a:r>
-          </a:p>
-          <a:p>
-            <a:pPr algn="l" marL="0" indent="0">
-              <a:defRPr sz="2900" b="1">
-                <a:solidFill>
-                  <a:srgbClr val="FFFFFF"/>
-                </a:solidFill>
-                <a:latin typeface="Inter"/>
-              </a:defRPr>
-              <a:lnSpc>
-                <a:spcPct val="112000"/>
-              </a:lnSpc>
-              <a:spcAft>
-                <a:spcPts val="1200"/>
-              </a:spcAft>
-              <a:buNone/>
-            </a:pPr>
-            <a:r>
-              <a:t>Curious.</a:t>
-            </a:r>
-          </a:p>
-          <a:p>
-            <a:pPr algn="l" marL="0" indent="0">
-              <a:defRPr sz="2900" b="1">
-                <a:solidFill>
-                  <a:srgbClr val="FFFFFF"/>
-                </a:solidFill>
-                <a:latin typeface="Inter"/>
-              </a:defRPr>
-              <a:lnSpc>
-                <a:spcPct val="112000"/>
-              </a:lnSpc>
-              <a:spcAft>
-                <a:spcPts val="1200"/>
-              </a:spcAft>
-              <a:buNone/>
-            </a:pPr>
-            <a:r>
-              <a:t>Grounded.</a:t>
-            </a:r>
-          </a:p>
-        </p:txBody>
-      </p:sp>
-      <p:sp>
-        <p:nvSpPr>
-          <p:cNvPr id="11" name="Plan B / Network energy gradient"/>
-          <p:cNvSpPr/>
-          <p:nvPr/>
-        </p:nvSpPr>
-        <p:spPr>
-          <a:xfrm>
-            <a:off x="7818120" y="5715000"/>
-            <a:ext cx="4379976" cy="365760"/>
-          </a:xfrm>
-          <a:prstGeom prst="rect">
-            <a:avLst/>
-          </a:prstGeom>
-          <a:gradFill rotWithShape="1">
-            <a:gsLst>
-              <a:gs pos="0">
-                <a:srgbClr val="F7931A"/>
-              </a:gs>
-              <a:gs pos="34000">
-                <a:srgbClr val="FF5DB1"/>
-              </a:gs>
-              <a:gs pos="68000">
-                <a:srgbClr val="7468FF"/>
-              </a:gs>
-              <a:gs pos="100000">
-                <a:srgbClr val="23F5FF"/>
-              </a:gs>
-            </a:gsLst>
-            <a:lin ang="0" scaled="1"/>
-          </a:gradFill>
-          <a:ln>
-            <a:noFill/>
-          </a:ln>
-          <a:effectLst/>
-        </p:spPr>
-        <p:txBody>
-          <a:bodyPr rtlCol="0" anchor="ctr"/>
-          <a:lstStyle/>
-          <a:p>
-            <a:pPr algn="ctr"/>
           </a:p>
         </p:txBody>
       </p:sp>
@@ -2000,93 +1922,7 @@
       </p:sp>
       <p:sp>
         <p:nvSpPr>
-          <p:cNvPr id="3" name="Plan B Foundation"/>
-          <p:cNvSpPr txBox="1"/>
-          <p:nvPr/>
-        </p:nvSpPr>
-        <p:spPr>
-          <a:xfrm>
-            <a:off x="594360" y="6382512"/>
-            <a:ext cx="3657600" cy="228600"/>
-          </a:xfrm>
-          <a:prstGeom prst="rect">
-            <a:avLst/>
-          </a:prstGeom>
-          <a:noFill/>
-        </p:spPr>
-        <p:txBody>
-          <a:bodyPr wrap="square" lIns="0" rIns="0" tIns="0" bIns="0">
-            <a:spAutoFit/>
-          </a:bodyPr>
-          <a:lstStyle/>
-          <a:p>
-            <a:pPr algn="l" marL="0" indent="0">
-              <a:defRPr sz="1100" b="1">
-                <a:solidFill>
-                  <a:srgbClr val="FFFFFF"/>
-                </a:solidFill>
-                <a:latin typeface="Inter"/>
-              </a:defRPr>
-              <a:lnSpc>
-                <a:spcPct val="112000"/>
-              </a:lnSpc>
-              <a:spcAft>
-                <a:spcPts val="1200"/>
-              </a:spcAft>
-              <a:buNone/>
-            </a:pPr>
-            <a:r>
-              <a:t>Plan B Foundation</a:t>
-            </a:r>
-          </a:p>
-        </p:txBody>
-      </p:sp>
-      <p:sp>
-        <p:nvSpPr>
-          <p:cNvPr id="4" name="Civic Digital Commons"/>
-          <p:cNvSpPr txBox="1"/>
-          <p:nvPr/>
-        </p:nvSpPr>
-        <p:spPr>
-          <a:xfrm>
-            <a:off x="8595360" y="6382512"/>
-            <a:ext cx="2971800" cy="228600"/>
-          </a:xfrm>
-          <a:prstGeom prst="rect">
-            <a:avLst/>
-          </a:prstGeom>
-          <a:noFill/>
-        </p:spPr>
-        <p:txBody>
-          <a:bodyPr wrap="square" lIns="0" rIns="0" tIns="0" bIns="0">
-            <a:spAutoFit/>
-          </a:bodyPr>
-          <a:lstStyle/>
-          <a:p>
-            <a:pPr algn="l" marL="0" indent="0">
-              <a:defRPr sz="1100" b="0">
-                <a:solidFill>
-                  <a:srgbClr val="FFFFFF"/>
-                </a:solidFill>
-                <a:latin typeface="Inter"/>
-              </a:defRPr>
-              <a:lnSpc>
-                <a:spcPct val="112000"/>
-              </a:lnSpc>
-              <a:spcAft>
-                <a:spcPts val="1200"/>
-              </a:spcAft>
-              <a:buNone/>
-            </a:pPr>
-            <a:r>
-              <a:t>Civic Digital Commons</a:t>
-            </a:r>
-          </a:p>
-        </p:txBody>
-      </p:sp>
-      <p:sp>
-        <p:nvSpPr>
-          <p:cNvPr id="5" name="Placeholder 0"/>
+          <p:cNvPr id="3" name="Placeholder 0"/>
           <p:cNvSpPr txBox="1"/>
           <p:nvPr>
             <p:ph type="title" idx="0"/>
@@ -2131,7 +1967,7 @@
       </p:sp>
       <p:sp>
         <p:nvSpPr>
-          <p:cNvPr id="6" name="Placeholder 1"/>
+          <p:cNvPr id="4" name="Placeholder 1"/>
           <p:cNvSpPr txBox="1"/>
           <p:nvPr>
             <p:ph type="body" idx="1"/>
@@ -2176,7 +2012,7 @@
       </p:sp>
       <p:sp>
         <p:nvSpPr>
-          <p:cNvPr id="7" name="Placeholder 2"/>
+          <p:cNvPr id="5" name="Placeholder 2"/>
           <p:cNvSpPr txBox="1"/>
           <p:nvPr>
             <p:ph type="body" idx="2"/>
@@ -2214,7 +2050,7 @@
               <a:buNone/>
             </a:pPr>
             <a:r>
-              <a:t>Use the layouts</a:t>
+              <a:t>Edit the slide</a:t>
             </a:r>
           </a:p>
           <a:p>
@@ -2234,14 +2070,14 @@
               <a:buNone/>
             </a:pPr>
             <a:r>
-              <a:t>Install Inter, then choose Home → New Slide. Replace bracketed prompts. Duplicate the chart or table example to retain its styling.</a:t>
-            </a:r>
-          </a:p>
-        </p:txBody>
-      </p:sp>
-      <p:sp>
-        <p:nvSpPr>
-          <p:cNvPr id="8" name="Placeholder 3"/>
+              <a:t>Duplicate the cover to keep its movable SVG logo, text, panel and top gradient. Copy other logo forms from the library slides. Use New Slide for content layouts.</a:t>
+            </a:r>
+          </a:p>
+        </p:txBody>
+      </p:sp>
+      <p:sp>
+        <p:nvSpPr>
+          <p:cNvPr id="6" name="Placeholder 3"/>
           <p:cNvSpPr txBox="1"/>
           <p:nvPr>
             <p:ph type="body" idx="3"/>
@@ -2279,7 +2115,7 @@
               <a:buNone/>
             </a:pPr>
             <a:r>
-              <a:t>Keep it clear</a:t>
+              <a:t>Edit every footer at once</a:t>
             </a:r>
           </a:p>
           <a:p>
@@ -2299,14 +2135,14 @@
               <a:buNone/>
             </a:pPr>
             <a:r>
-              <a:t>One idea per slide. Keep the selected light or dark palette. Preserve the gradient band and keep text on solid grounds. Aim for 20pt or larger body text.</a:t>
-            </a:r>
-          </a:p>
-        </p:txBody>
-      </p:sp>
-      <p:sp>
-        <p:nvSpPr>
-          <p:cNvPr id="9" name="Rectangle 8"/>
+              <a:t>View → Slide Master → select the top parent master. Edit the two footer text boxes, then Close Master View. Delete this guide and the logo library before presenting.</a:t>
+            </a:r>
+          </a:p>
+        </p:txBody>
+      </p:sp>
+      <p:sp>
+        <p:nvSpPr>
+          <p:cNvPr id="7" name="Rectangle 6"/>
           <p:cNvSpPr/>
           <p:nvPr/>
         </p:nvSpPr>
@@ -2336,7 +2172,7 @@
       </p:sp>
       <p:sp>
         <p:nvSpPr>
-          <p:cNvPr id="10" name="Rectangle 9"/>
+          <p:cNvPr id="8" name="Rectangle 7"/>
           <p:cNvSpPr/>
           <p:nvPr/>
         </p:nvSpPr>
@@ -2366,7 +2202,7 @@
       </p:sp>
       <p:sp>
         <p:nvSpPr>
-          <p:cNvPr id="11" name="Rectangle 10"/>
+          <p:cNvPr id="9" name="Rectangle 8"/>
           <p:cNvSpPr/>
           <p:nvPr/>
         </p:nvSpPr>
@@ -2396,7 +2232,7 @@
       </p:sp>
       <p:sp>
         <p:nvSpPr>
-          <p:cNvPr id="12" name="Rectangle 11"/>
+          <p:cNvPr id="10" name="Rectangle 9"/>
           <p:cNvSpPr/>
           <p:nvPr/>
         </p:nvSpPr>
@@ -2426,7 +2262,7 @@
       </p:sp>
       <p:sp>
         <p:nvSpPr>
-          <p:cNvPr id="13" name="Full guidance: plan-b.foundation/brandin"/>
+          <p:cNvPr id="11" name="Full guidance: plan-b.foundation/brandin"/>
           <p:cNvSpPr txBox="1"/>
           <p:nvPr/>
         </p:nvSpPr>
@@ -2633,93 +2469,7 @@
       </p:sp>
       <p:sp>
         <p:nvSpPr>
-          <p:cNvPr id="3" name="Plan B Foundation"/>
-          <p:cNvSpPr txBox="1"/>
-          <p:nvPr/>
-        </p:nvSpPr>
-        <p:spPr>
-          <a:xfrm>
-            <a:off x="594360" y="6382512"/>
-            <a:ext cx="3657600" cy="228600"/>
-          </a:xfrm>
-          <a:prstGeom prst="rect">
-            <a:avLst/>
-          </a:prstGeom>
-          <a:noFill/>
-        </p:spPr>
-        <p:txBody>
-          <a:bodyPr wrap="square" lIns="0" rIns="0" tIns="0" bIns="0">
-            <a:spAutoFit/>
-          </a:bodyPr>
-          <a:lstStyle/>
-          <a:p>
-            <a:pPr algn="l" marL="0" indent="0">
-              <a:defRPr sz="1100" b="1">
-                <a:solidFill>
-                  <a:srgbClr val="FFFFFF"/>
-                </a:solidFill>
-                <a:latin typeface="Inter"/>
-              </a:defRPr>
-              <a:lnSpc>
-                <a:spcPct val="112000"/>
-              </a:lnSpc>
-              <a:spcAft>
-                <a:spcPts val="1200"/>
-              </a:spcAft>
-              <a:buNone/>
-            </a:pPr>
-            <a:r>
-              <a:t>Plan B Foundation</a:t>
-            </a:r>
-          </a:p>
-        </p:txBody>
-      </p:sp>
-      <p:sp>
-        <p:nvSpPr>
-          <p:cNvPr id="4" name="Civic Digital Commons"/>
-          <p:cNvSpPr txBox="1"/>
-          <p:nvPr/>
-        </p:nvSpPr>
-        <p:spPr>
-          <a:xfrm>
-            <a:off x="8595360" y="6382512"/>
-            <a:ext cx="2971800" cy="228600"/>
-          </a:xfrm>
-          <a:prstGeom prst="rect">
-            <a:avLst/>
-          </a:prstGeom>
-          <a:noFill/>
-        </p:spPr>
-        <p:txBody>
-          <a:bodyPr wrap="square" lIns="0" rIns="0" tIns="0" bIns="0">
-            <a:spAutoFit/>
-          </a:bodyPr>
-          <a:lstStyle/>
-          <a:p>
-            <a:pPr algn="l" marL="0" indent="0">
-              <a:defRPr sz="1100" b="0">
-                <a:solidFill>
-                  <a:srgbClr val="FFFFFF"/>
-                </a:solidFill>
-                <a:latin typeface="Inter"/>
-              </a:defRPr>
-              <a:lnSpc>
-                <a:spcPct val="112000"/>
-              </a:lnSpc>
-              <a:spcAft>
-                <a:spcPts val="1200"/>
-              </a:spcAft>
-              <a:buNone/>
-            </a:pPr>
-            <a:r>
-              <a:t>Civic Digital Commons</a:t>
-            </a:r>
-          </a:p>
-        </p:txBody>
-      </p:sp>
-      <p:sp>
-        <p:nvSpPr>
-          <p:cNvPr id="5" name="Placeholder 0"/>
+          <p:cNvPr id="3" name="Placeholder 0"/>
           <p:cNvSpPr txBox="1"/>
           <p:nvPr>
             <p:ph type="title" idx="0"/>
@@ -2764,7 +2514,7 @@
       </p:sp>
       <p:sp>
         <p:nvSpPr>
-          <p:cNvPr id="6" name="Placeholder 1"/>
+          <p:cNvPr id="4" name="Placeholder 1"/>
           <p:cNvSpPr txBox="1"/>
           <p:nvPr>
             <p:ph type="body" idx="1"/>
@@ -2809,7 +2559,7 @@
       </p:sp>
       <p:sp>
         <p:nvSpPr>
-          <p:cNvPr id="7" name="Plan B / Network energy gradient"/>
+          <p:cNvPr id="5" name="Plan B / Network energy gradient"/>
           <p:cNvSpPr/>
           <p:nvPr/>
         </p:nvSpPr>
@@ -2935,93 +2685,7 @@
       </p:sp>
       <p:sp>
         <p:nvSpPr>
-          <p:cNvPr id="3" name="Plan B Foundation"/>
-          <p:cNvSpPr txBox="1"/>
-          <p:nvPr/>
-        </p:nvSpPr>
-        <p:spPr>
-          <a:xfrm>
-            <a:off x="594360" y="6382512"/>
-            <a:ext cx="3657600" cy="228600"/>
-          </a:xfrm>
-          <a:prstGeom prst="rect">
-            <a:avLst/>
-          </a:prstGeom>
-          <a:noFill/>
-        </p:spPr>
-        <p:txBody>
-          <a:bodyPr wrap="square" lIns="0" rIns="0" tIns="0" bIns="0">
-            <a:spAutoFit/>
-          </a:bodyPr>
-          <a:lstStyle/>
-          <a:p>
-            <a:pPr algn="l" marL="0" indent="0">
-              <a:defRPr sz="1100" b="1">
-                <a:solidFill>
-                  <a:srgbClr val="FFFFFF"/>
-                </a:solidFill>
-                <a:latin typeface="Inter"/>
-              </a:defRPr>
-              <a:lnSpc>
-                <a:spcPct val="112000"/>
-              </a:lnSpc>
-              <a:spcAft>
-                <a:spcPts val="1200"/>
-              </a:spcAft>
-              <a:buNone/>
-            </a:pPr>
-            <a:r>
-              <a:t>Plan B Foundation</a:t>
-            </a:r>
-          </a:p>
-        </p:txBody>
-      </p:sp>
-      <p:sp>
-        <p:nvSpPr>
-          <p:cNvPr id="4" name="Civic Digital Commons"/>
-          <p:cNvSpPr txBox="1"/>
-          <p:nvPr/>
-        </p:nvSpPr>
-        <p:spPr>
-          <a:xfrm>
-            <a:off x="8595360" y="6382512"/>
-            <a:ext cx="2971800" cy="228600"/>
-          </a:xfrm>
-          <a:prstGeom prst="rect">
-            <a:avLst/>
-          </a:prstGeom>
-          <a:noFill/>
-        </p:spPr>
-        <p:txBody>
-          <a:bodyPr wrap="square" lIns="0" rIns="0" tIns="0" bIns="0">
-            <a:spAutoFit/>
-          </a:bodyPr>
-          <a:lstStyle/>
-          <a:p>
-            <a:pPr algn="l" marL="0" indent="0">
-              <a:defRPr sz="1100" b="0">
-                <a:solidFill>
-                  <a:srgbClr val="FFFFFF"/>
-                </a:solidFill>
-                <a:latin typeface="Inter"/>
-              </a:defRPr>
-              <a:lnSpc>
-                <a:spcPct val="112000"/>
-              </a:lnSpc>
-              <a:spcAft>
-                <a:spcPts val="1200"/>
-              </a:spcAft>
-              <a:buNone/>
-            </a:pPr>
-            <a:r>
-              <a:t>Civic Digital Commons</a:t>
-            </a:r>
-          </a:p>
-        </p:txBody>
-      </p:sp>
-      <p:sp>
-        <p:nvSpPr>
-          <p:cNvPr id="5" name="Placeholder 0"/>
+          <p:cNvPr id="3" name="Placeholder 0"/>
           <p:cNvSpPr txBox="1"/>
           <p:nvPr>
             <p:ph type="title" idx="0"/>
@@ -3066,7 +2730,7 @@
       </p:sp>
       <p:sp>
         <p:nvSpPr>
-          <p:cNvPr id="6" name="Placeholder 1"/>
+          <p:cNvPr id="4" name="Placeholder 1"/>
           <p:cNvSpPr txBox="1"/>
           <p:nvPr>
             <p:ph type="body" idx="1"/>
@@ -3111,7 +2775,7 @@
       </p:sp>
       <p:sp>
         <p:nvSpPr>
-          <p:cNvPr id="7" name="Placeholder 2"/>
+          <p:cNvPr id="5" name="Placeholder 2"/>
           <p:cNvSpPr txBox="1"/>
           <p:nvPr>
             <p:ph type="body" idx="2"/>
@@ -3278,93 +2942,7 @@
       </p:sp>
       <p:sp>
         <p:nvSpPr>
-          <p:cNvPr id="3" name="Plan B Foundation"/>
-          <p:cNvSpPr txBox="1"/>
-          <p:nvPr/>
-        </p:nvSpPr>
-        <p:spPr>
-          <a:xfrm>
-            <a:off x="594360" y="6382512"/>
-            <a:ext cx="3657600" cy="228600"/>
-          </a:xfrm>
-          <a:prstGeom prst="rect">
-            <a:avLst/>
-          </a:prstGeom>
-          <a:noFill/>
-        </p:spPr>
-        <p:txBody>
-          <a:bodyPr wrap="square" lIns="0" rIns="0" tIns="0" bIns="0">
-            <a:spAutoFit/>
-          </a:bodyPr>
-          <a:lstStyle/>
-          <a:p>
-            <a:pPr algn="l" marL="0" indent="0">
-              <a:defRPr sz="1100" b="1">
-                <a:solidFill>
-                  <a:srgbClr val="FFFFFF"/>
-                </a:solidFill>
-                <a:latin typeface="Inter"/>
-              </a:defRPr>
-              <a:lnSpc>
-                <a:spcPct val="112000"/>
-              </a:lnSpc>
-              <a:spcAft>
-                <a:spcPts val="1200"/>
-              </a:spcAft>
-              <a:buNone/>
-            </a:pPr>
-            <a:r>
-              <a:t>Plan B Foundation</a:t>
-            </a:r>
-          </a:p>
-        </p:txBody>
-      </p:sp>
-      <p:sp>
-        <p:nvSpPr>
-          <p:cNvPr id="4" name="Civic Digital Commons"/>
-          <p:cNvSpPr txBox="1"/>
-          <p:nvPr/>
-        </p:nvSpPr>
-        <p:spPr>
-          <a:xfrm>
-            <a:off x="8595360" y="6382512"/>
-            <a:ext cx="2971800" cy="228600"/>
-          </a:xfrm>
-          <a:prstGeom prst="rect">
-            <a:avLst/>
-          </a:prstGeom>
-          <a:noFill/>
-        </p:spPr>
-        <p:txBody>
-          <a:bodyPr wrap="square" lIns="0" rIns="0" tIns="0" bIns="0">
-            <a:spAutoFit/>
-          </a:bodyPr>
-          <a:lstStyle/>
-          <a:p>
-            <a:pPr algn="l" marL="0" indent="0">
-              <a:defRPr sz="1100" b="0">
-                <a:solidFill>
-                  <a:srgbClr val="FFFFFF"/>
-                </a:solidFill>
-                <a:latin typeface="Inter"/>
-              </a:defRPr>
-              <a:lnSpc>
-                <a:spcPct val="112000"/>
-              </a:lnSpc>
-              <a:spcAft>
-                <a:spcPts val="1200"/>
-              </a:spcAft>
-              <a:buNone/>
-            </a:pPr>
-            <a:r>
-              <a:t>Civic Digital Commons</a:t>
-            </a:r>
-          </a:p>
-        </p:txBody>
-      </p:sp>
-      <p:sp>
-        <p:nvSpPr>
-          <p:cNvPr id="5" name="Placeholder 0"/>
+          <p:cNvPr id="3" name="Placeholder 0"/>
           <p:cNvSpPr txBox="1"/>
           <p:nvPr>
             <p:ph type="title" idx="0"/>
@@ -3409,7 +2987,7 @@
       </p:sp>
       <p:sp>
         <p:nvSpPr>
-          <p:cNvPr id="6" name="Placeholder 1"/>
+          <p:cNvPr id="4" name="Placeholder 1"/>
           <p:cNvSpPr txBox="1"/>
           <p:nvPr>
             <p:ph type="body" idx="1"/>
@@ -3454,7 +3032,7 @@
       </p:sp>
       <p:sp>
         <p:nvSpPr>
-          <p:cNvPr id="7" name="Placeholder 2"/>
+          <p:cNvPr id="5" name="Placeholder 2"/>
           <p:cNvSpPr txBox="1"/>
           <p:nvPr>
             <p:ph type="body" idx="2"/>
@@ -3499,7 +3077,7 @@
       </p:sp>
       <p:sp>
         <p:nvSpPr>
-          <p:cNvPr id="8" name="Placeholder 3"/>
+          <p:cNvPr id="6" name="Placeholder 3"/>
           <p:cNvSpPr txBox="1"/>
           <p:nvPr>
             <p:ph type="body" idx="3"/>
@@ -3544,7 +3122,7 @@
       </p:sp>
       <p:sp>
         <p:nvSpPr>
-          <p:cNvPr id="9" name="Placeholder 4"/>
+          <p:cNvPr id="7" name="Placeholder 4"/>
           <p:cNvSpPr txBox="1"/>
           <p:nvPr>
             <p:ph type="body" idx="4"/>
@@ -3589,7 +3167,7 @@
       </p:sp>
       <p:sp>
         <p:nvSpPr>
-          <p:cNvPr id="10" name="Rectangle 9"/>
+          <p:cNvPr id="8" name="Rectangle 7"/>
           <p:cNvSpPr/>
           <p:nvPr/>
         </p:nvSpPr>
@@ -3701,93 +3279,7 @@
       </p:sp>
       <p:sp>
         <p:nvSpPr>
-          <p:cNvPr id="3" name="Plan B Foundation"/>
-          <p:cNvSpPr txBox="1"/>
-          <p:nvPr/>
-        </p:nvSpPr>
-        <p:spPr>
-          <a:xfrm>
-            <a:off x="594360" y="6382512"/>
-            <a:ext cx="3657600" cy="228600"/>
-          </a:xfrm>
-          <a:prstGeom prst="rect">
-            <a:avLst/>
-          </a:prstGeom>
-          <a:noFill/>
-        </p:spPr>
-        <p:txBody>
-          <a:bodyPr wrap="square" lIns="0" rIns="0" tIns="0" bIns="0">
-            <a:spAutoFit/>
-          </a:bodyPr>
-          <a:lstStyle/>
-          <a:p>
-            <a:pPr algn="l" marL="0" indent="0">
-              <a:defRPr sz="1100" b="1">
-                <a:solidFill>
-                  <a:srgbClr val="FFFFFF"/>
-                </a:solidFill>
-                <a:latin typeface="Inter"/>
-              </a:defRPr>
-              <a:lnSpc>
-                <a:spcPct val="112000"/>
-              </a:lnSpc>
-              <a:spcAft>
-                <a:spcPts val="1200"/>
-              </a:spcAft>
-              <a:buNone/>
-            </a:pPr>
-            <a:r>
-              <a:t>Plan B Foundation</a:t>
-            </a:r>
-          </a:p>
-        </p:txBody>
-      </p:sp>
-      <p:sp>
-        <p:nvSpPr>
-          <p:cNvPr id="4" name="Civic Digital Commons"/>
-          <p:cNvSpPr txBox="1"/>
-          <p:nvPr/>
-        </p:nvSpPr>
-        <p:spPr>
-          <a:xfrm>
-            <a:off x="8595360" y="6382512"/>
-            <a:ext cx="2971800" cy="228600"/>
-          </a:xfrm>
-          <a:prstGeom prst="rect">
-            <a:avLst/>
-          </a:prstGeom>
-          <a:noFill/>
-        </p:spPr>
-        <p:txBody>
-          <a:bodyPr wrap="square" lIns="0" rIns="0" tIns="0" bIns="0">
-            <a:spAutoFit/>
-          </a:bodyPr>
-          <a:lstStyle/>
-          <a:p>
-            <a:pPr algn="l" marL="0" indent="0">
-              <a:defRPr sz="1100" b="0">
-                <a:solidFill>
-                  <a:srgbClr val="FFFFFF"/>
-                </a:solidFill>
-                <a:latin typeface="Inter"/>
-              </a:defRPr>
-              <a:lnSpc>
-                <a:spcPct val="112000"/>
-              </a:lnSpc>
-              <a:spcAft>
-                <a:spcPts val="1200"/>
-              </a:spcAft>
-              <a:buNone/>
-            </a:pPr>
-            <a:r>
-              <a:t>Civic Digital Commons</a:t>
-            </a:r>
-          </a:p>
-        </p:txBody>
-      </p:sp>
-      <p:sp>
-        <p:nvSpPr>
-          <p:cNvPr id="5" name="Placeholder 0"/>
+          <p:cNvPr id="3" name="Placeholder 0"/>
           <p:cNvSpPr txBox="1"/>
           <p:nvPr>
             <p:ph type="title" idx="0"/>
@@ -3832,7 +3324,7 @@
       </p:sp>
       <p:sp>
         <p:nvSpPr>
-          <p:cNvPr id="6" name="Rounded Rectangle 5"/>
+          <p:cNvPr id="4" name="Rounded Rectangle 3"/>
           <p:cNvSpPr/>
           <p:nvPr/>
         </p:nvSpPr>
@@ -3864,7 +3356,7 @@
       </p:sp>
       <p:sp>
         <p:nvSpPr>
-          <p:cNvPr id="7" name="Insert a documentary photograph"/>
+          <p:cNvPr id="5" name="Insert a documentary photograph"/>
           <p:cNvSpPr txBox="1"/>
           <p:nvPr/>
         </p:nvSpPr>
@@ -3907,7 +3399,7 @@
       </p:sp>
       <p:sp>
         <p:nvSpPr>
-          <p:cNvPr id="8" name="Placeholder 1"/>
+          <p:cNvPr id="6" name="Placeholder 1"/>
           <p:cNvSpPr txBox="1"/>
           <p:nvPr>
             <p:ph type="pic" idx="1"/>
@@ -3952,7 +3444,7 @@
       </p:sp>
       <p:sp>
         <p:nvSpPr>
-          <p:cNvPr id="9" name="Placeholder 2"/>
+          <p:cNvPr id="7" name="Placeholder 2"/>
           <p:cNvSpPr txBox="1"/>
           <p:nvPr>
             <p:ph type="body" idx="2"/>
@@ -3997,7 +3489,7 @@
       </p:sp>
       <p:sp>
         <p:nvSpPr>
-          <p:cNvPr id="10" name="Placeholder 3"/>
+          <p:cNvPr id="8" name="Placeholder 3"/>
           <p:cNvSpPr txBox="1"/>
           <p:nvPr>
             <p:ph type="body" idx="3"/>
@@ -4042,7 +3534,7 @@
       </p:sp>
       <p:sp>
         <p:nvSpPr>
-          <p:cNvPr id="11" name="Placeholder 4"/>
+          <p:cNvPr id="9" name="Placeholder 4"/>
           <p:cNvSpPr txBox="1"/>
           <p:nvPr>
             <p:ph type="body" idx="4"/>
@@ -4169,93 +3661,7 @@
       </p:sp>
       <p:sp>
         <p:nvSpPr>
-          <p:cNvPr id="3" name="Plan B Foundation"/>
-          <p:cNvSpPr txBox="1"/>
-          <p:nvPr/>
-        </p:nvSpPr>
-        <p:spPr>
-          <a:xfrm>
-            <a:off x="594360" y="6382512"/>
-            <a:ext cx="3657600" cy="228600"/>
-          </a:xfrm>
-          <a:prstGeom prst="rect">
-            <a:avLst/>
-          </a:prstGeom>
-          <a:noFill/>
-        </p:spPr>
-        <p:txBody>
-          <a:bodyPr wrap="square" lIns="0" rIns="0" tIns="0" bIns="0">
-            <a:spAutoFit/>
-          </a:bodyPr>
-          <a:lstStyle/>
-          <a:p>
-            <a:pPr algn="l" marL="0" indent="0">
-              <a:defRPr sz="1100" b="1">
-                <a:solidFill>
-                  <a:srgbClr val="FFFFFF"/>
-                </a:solidFill>
-                <a:latin typeface="Inter"/>
-              </a:defRPr>
-              <a:lnSpc>
-                <a:spcPct val="112000"/>
-              </a:lnSpc>
-              <a:spcAft>
-                <a:spcPts val="1200"/>
-              </a:spcAft>
-              <a:buNone/>
-            </a:pPr>
-            <a:r>
-              <a:t>Plan B Foundation</a:t>
-            </a:r>
-          </a:p>
-        </p:txBody>
-      </p:sp>
-      <p:sp>
-        <p:nvSpPr>
-          <p:cNvPr id="4" name="Civic Digital Commons"/>
-          <p:cNvSpPr txBox="1"/>
-          <p:nvPr/>
-        </p:nvSpPr>
-        <p:spPr>
-          <a:xfrm>
-            <a:off x="8595360" y="6382512"/>
-            <a:ext cx="2971800" cy="228600"/>
-          </a:xfrm>
-          <a:prstGeom prst="rect">
-            <a:avLst/>
-          </a:prstGeom>
-          <a:noFill/>
-        </p:spPr>
-        <p:txBody>
-          <a:bodyPr wrap="square" lIns="0" rIns="0" tIns="0" bIns="0">
-            <a:spAutoFit/>
-          </a:bodyPr>
-          <a:lstStyle/>
-          <a:p>
-            <a:pPr algn="l" marL="0" indent="0">
-              <a:defRPr sz="1100" b="0">
-                <a:solidFill>
-                  <a:srgbClr val="FFFFFF"/>
-                </a:solidFill>
-                <a:latin typeface="Inter"/>
-              </a:defRPr>
-              <a:lnSpc>
-                <a:spcPct val="112000"/>
-              </a:lnSpc>
-              <a:spcAft>
-                <a:spcPts val="1200"/>
-              </a:spcAft>
-              <a:buNone/>
-            </a:pPr>
-            <a:r>
-              <a:t>Civic Digital Commons</a:t>
-            </a:r>
-          </a:p>
-        </p:txBody>
-      </p:sp>
-      <p:sp>
-        <p:nvSpPr>
-          <p:cNvPr id="5" name="Placeholder 0"/>
+          <p:cNvPr id="3" name="Placeholder 0"/>
           <p:cNvSpPr txBox="1"/>
           <p:nvPr>
             <p:ph type="title" idx="0"/>
@@ -4300,7 +3706,7 @@
       </p:sp>
       <p:sp>
         <p:nvSpPr>
-          <p:cNvPr id="6" name="Placeholder 1"/>
+          <p:cNvPr id="4" name="Placeholder 1"/>
           <p:cNvSpPr txBox="1"/>
           <p:nvPr>
             <p:ph type="body" idx="1"/>
@@ -4345,7 +3751,7 @@
       </p:sp>
       <p:sp>
         <p:nvSpPr>
-          <p:cNvPr id="7" name="Placeholder 2"/>
+          <p:cNvPr id="5" name="Placeholder 2"/>
           <p:cNvSpPr txBox="1"/>
           <p:nvPr>
             <p:ph type="chart" idx="2"/>
@@ -4390,7 +3796,7 @@
       </p:sp>
       <p:sp>
         <p:nvSpPr>
-          <p:cNvPr id="8" name="Placeholder 3"/>
+          <p:cNvPr id="6" name="Placeholder 3"/>
           <p:cNvSpPr txBox="1"/>
           <p:nvPr>
             <p:ph type="body" idx="3"/>
@@ -4435,7 +3841,7 @@
       </p:sp>
       <p:sp>
         <p:nvSpPr>
-          <p:cNvPr id="9" name="Placeholder 4"/>
+          <p:cNvPr id="7" name="Placeholder 4"/>
           <p:cNvSpPr txBox="1"/>
           <p:nvPr>
             <p:ph type="body" idx="4"/>
@@ -4480,7 +3886,7 @@
       </p:sp>
       <p:sp>
         <p:nvSpPr>
-          <p:cNvPr id="10" name="Placeholder 5"/>
+          <p:cNvPr id="8" name="Placeholder 5"/>
           <p:cNvSpPr txBox="1"/>
           <p:nvPr>
             <p:ph type="body" idx="5"/>
@@ -4607,93 +4013,7 @@
       </p:sp>
       <p:sp>
         <p:nvSpPr>
-          <p:cNvPr id="3" name="Plan B Foundation"/>
-          <p:cNvSpPr txBox="1"/>
-          <p:nvPr/>
-        </p:nvSpPr>
-        <p:spPr>
-          <a:xfrm>
-            <a:off x="594360" y="6382512"/>
-            <a:ext cx="3657600" cy="228600"/>
-          </a:xfrm>
-          <a:prstGeom prst="rect">
-            <a:avLst/>
-          </a:prstGeom>
-          <a:noFill/>
-        </p:spPr>
-        <p:txBody>
-          <a:bodyPr wrap="square" lIns="0" rIns="0" tIns="0" bIns="0">
-            <a:spAutoFit/>
-          </a:bodyPr>
-          <a:lstStyle/>
-          <a:p>
-            <a:pPr algn="l" marL="0" indent="0">
-              <a:defRPr sz="1100" b="1">
-                <a:solidFill>
-                  <a:srgbClr val="FFFFFF"/>
-                </a:solidFill>
-                <a:latin typeface="Inter"/>
-              </a:defRPr>
-              <a:lnSpc>
-                <a:spcPct val="112000"/>
-              </a:lnSpc>
-              <a:spcAft>
-                <a:spcPts val="1200"/>
-              </a:spcAft>
-              <a:buNone/>
-            </a:pPr>
-            <a:r>
-              <a:t>Plan B Foundation</a:t>
-            </a:r>
-          </a:p>
-        </p:txBody>
-      </p:sp>
-      <p:sp>
-        <p:nvSpPr>
-          <p:cNvPr id="4" name="Civic Digital Commons"/>
-          <p:cNvSpPr txBox="1"/>
-          <p:nvPr/>
-        </p:nvSpPr>
-        <p:spPr>
-          <a:xfrm>
-            <a:off x="8595360" y="6382512"/>
-            <a:ext cx="2971800" cy="228600"/>
-          </a:xfrm>
-          <a:prstGeom prst="rect">
-            <a:avLst/>
-          </a:prstGeom>
-          <a:noFill/>
-        </p:spPr>
-        <p:txBody>
-          <a:bodyPr wrap="square" lIns="0" rIns="0" tIns="0" bIns="0">
-            <a:spAutoFit/>
-          </a:bodyPr>
-          <a:lstStyle/>
-          <a:p>
-            <a:pPr algn="l" marL="0" indent="0">
-              <a:defRPr sz="1100" b="0">
-                <a:solidFill>
-                  <a:srgbClr val="FFFFFF"/>
-                </a:solidFill>
-                <a:latin typeface="Inter"/>
-              </a:defRPr>
-              <a:lnSpc>
-                <a:spcPct val="112000"/>
-              </a:lnSpc>
-              <a:spcAft>
-                <a:spcPts val="1200"/>
-              </a:spcAft>
-              <a:buNone/>
-            </a:pPr>
-            <a:r>
-              <a:t>Civic Digital Commons</a:t>
-            </a:r>
-          </a:p>
-        </p:txBody>
-      </p:sp>
-      <p:sp>
-        <p:nvSpPr>
-          <p:cNvPr id="5" name="Placeholder 0"/>
+          <p:cNvPr id="3" name="Placeholder 0"/>
           <p:cNvSpPr txBox="1"/>
           <p:nvPr>
             <p:ph type="title" idx="0"/>
@@ -4738,7 +4058,7 @@
       </p:sp>
       <p:sp>
         <p:nvSpPr>
-          <p:cNvPr id="6" name="Placeholder 1"/>
+          <p:cNvPr id="4" name="Placeholder 1"/>
           <p:cNvSpPr txBox="1"/>
           <p:nvPr>
             <p:ph type="body" idx="1"/>
@@ -4783,7 +4103,7 @@
       </p:sp>
       <p:sp>
         <p:nvSpPr>
-          <p:cNvPr id="7" name="Placeholder 2"/>
+          <p:cNvPr id="5" name="Placeholder 2"/>
           <p:cNvSpPr txBox="1"/>
           <p:nvPr>
             <p:ph type="tbl" idx="2"/>
@@ -4828,7 +4148,7 @@
       </p:sp>
       <p:sp>
         <p:nvSpPr>
-          <p:cNvPr id="8" name="Placeholder 3"/>
+          <p:cNvPr id="6" name="Placeholder 3"/>
           <p:cNvSpPr txBox="1"/>
           <p:nvPr>
             <p:ph type="body" idx="3"/>
@@ -4955,93 +4275,7 @@
       </p:sp>
       <p:sp>
         <p:nvSpPr>
-          <p:cNvPr id="3" name="Plan B Foundation"/>
-          <p:cNvSpPr txBox="1"/>
-          <p:nvPr/>
-        </p:nvSpPr>
-        <p:spPr>
-          <a:xfrm>
-            <a:off x="594360" y="6382512"/>
-            <a:ext cx="3657600" cy="228600"/>
-          </a:xfrm>
-          <a:prstGeom prst="rect">
-            <a:avLst/>
-          </a:prstGeom>
-          <a:noFill/>
-        </p:spPr>
-        <p:txBody>
-          <a:bodyPr wrap="square" lIns="0" rIns="0" tIns="0" bIns="0">
-            <a:spAutoFit/>
-          </a:bodyPr>
-          <a:lstStyle/>
-          <a:p>
-            <a:pPr algn="l" marL="0" indent="0">
-              <a:defRPr sz="1100" b="1">
-                <a:solidFill>
-                  <a:srgbClr val="FFFFFF"/>
-                </a:solidFill>
-                <a:latin typeface="Inter"/>
-              </a:defRPr>
-              <a:lnSpc>
-                <a:spcPct val="112000"/>
-              </a:lnSpc>
-              <a:spcAft>
-                <a:spcPts val="1200"/>
-              </a:spcAft>
-              <a:buNone/>
-            </a:pPr>
-            <a:r>
-              <a:t>Plan B Foundation</a:t>
-            </a:r>
-          </a:p>
-        </p:txBody>
-      </p:sp>
-      <p:sp>
-        <p:nvSpPr>
-          <p:cNvPr id="4" name="Civic Digital Commons"/>
-          <p:cNvSpPr txBox="1"/>
-          <p:nvPr/>
-        </p:nvSpPr>
-        <p:spPr>
-          <a:xfrm>
-            <a:off x="8595360" y="6382512"/>
-            <a:ext cx="2971800" cy="228600"/>
-          </a:xfrm>
-          <a:prstGeom prst="rect">
-            <a:avLst/>
-          </a:prstGeom>
-          <a:noFill/>
-        </p:spPr>
-        <p:txBody>
-          <a:bodyPr wrap="square" lIns="0" rIns="0" tIns="0" bIns="0">
-            <a:spAutoFit/>
-          </a:bodyPr>
-          <a:lstStyle/>
-          <a:p>
-            <a:pPr algn="l" marL="0" indent="0">
-              <a:defRPr sz="1100" b="0">
-                <a:solidFill>
-                  <a:srgbClr val="FFFFFF"/>
-                </a:solidFill>
-                <a:latin typeface="Inter"/>
-              </a:defRPr>
-              <a:lnSpc>
-                <a:spcPct val="112000"/>
-              </a:lnSpc>
-              <a:spcAft>
-                <a:spcPts val="1200"/>
-              </a:spcAft>
-              <a:buNone/>
-            </a:pPr>
-            <a:r>
-              <a:t>Civic Digital Commons</a:t>
-            </a:r>
-          </a:p>
-        </p:txBody>
-      </p:sp>
-      <p:sp>
-        <p:nvSpPr>
-          <p:cNvPr id="5" name="Placeholder 0"/>
+          <p:cNvPr id="3" name="Placeholder 0"/>
           <p:cNvSpPr txBox="1"/>
           <p:nvPr>
             <p:ph type="title" idx="0"/>
@@ -5106,7 +4340,7 @@
       </p:sp>
       <p:sp>
         <p:nvSpPr>
-          <p:cNvPr id="6" name="Placeholder 1"/>
+          <p:cNvPr id="4" name="Placeholder 1"/>
           <p:cNvSpPr txBox="1"/>
           <p:nvPr>
             <p:ph type="body" idx="1"/>
@@ -5171,7 +4405,7 @@
       </p:sp>
       <p:sp>
         <p:nvSpPr>
-          <p:cNvPr id="7" name="Plan B / Network energy gradient"/>
+          <p:cNvPr id="5" name="Plan B / Network energy gradient"/>
           <p:cNvSpPr/>
           <p:nvPr/>
         </p:nvSpPr>
@@ -5297,93 +4531,7 @@
       </p:sp>
       <p:sp>
         <p:nvSpPr>
-          <p:cNvPr id="3" name="Plan B Foundation"/>
-          <p:cNvSpPr txBox="1"/>
-          <p:nvPr/>
-        </p:nvSpPr>
-        <p:spPr>
-          <a:xfrm>
-            <a:off x="594360" y="6382512"/>
-            <a:ext cx="3657600" cy="228600"/>
-          </a:xfrm>
-          <a:prstGeom prst="rect">
-            <a:avLst/>
-          </a:prstGeom>
-          <a:noFill/>
-        </p:spPr>
-        <p:txBody>
-          <a:bodyPr wrap="square" lIns="0" rIns="0" tIns="0" bIns="0">
-            <a:spAutoFit/>
-          </a:bodyPr>
-          <a:lstStyle/>
-          <a:p>
-            <a:pPr algn="l" marL="0" indent="0">
-              <a:defRPr sz="1100" b="1">
-                <a:solidFill>
-                  <a:srgbClr val="FFFFFF"/>
-                </a:solidFill>
-                <a:latin typeface="Inter"/>
-              </a:defRPr>
-              <a:lnSpc>
-                <a:spcPct val="112000"/>
-              </a:lnSpc>
-              <a:spcAft>
-                <a:spcPts val="1200"/>
-              </a:spcAft>
-              <a:buNone/>
-            </a:pPr>
-            <a:r>
-              <a:t>Plan B Foundation</a:t>
-            </a:r>
-          </a:p>
-        </p:txBody>
-      </p:sp>
-      <p:sp>
-        <p:nvSpPr>
-          <p:cNvPr id="4" name="Civic Digital Commons"/>
-          <p:cNvSpPr txBox="1"/>
-          <p:nvPr/>
-        </p:nvSpPr>
-        <p:spPr>
-          <a:xfrm>
-            <a:off x="8595360" y="6382512"/>
-            <a:ext cx="2971800" cy="228600"/>
-          </a:xfrm>
-          <a:prstGeom prst="rect">
-            <a:avLst/>
-          </a:prstGeom>
-          <a:noFill/>
-        </p:spPr>
-        <p:txBody>
-          <a:bodyPr wrap="square" lIns="0" rIns="0" tIns="0" bIns="0">
-            <a:spAutoFit/>
-          </a:bodyPr>
-          <a:lstStyle/>
-          <a:p>
-            <a:pPr algn="l" marL="0" indent="0">
-              <a:defRPr sz="1100" b="0">
-                <a:solidFill>
-                  <a:srgbClr val="FFFFFF"/>
-                </a:solidFill>
-                <a:latin typeface="Inter"/>
-              </a:defRPr>
-              <a:lnSpc>
-                <a:spcPct val="112000"/>
-              </a:lnSpc>
-              <a:spcAft>
-                <a:spcPts val="1200"/>
-              </a:spcAft>
-              <a:buNone/>
-            </a:pPr>
-            <a:r>
-              <a:t>Civic Digital Commons</a:t>
-            </a:r>
-          </a:p>
-        </p:txBody>
-      </p:sp>
-      <p:sp>
-        <p:nvSpPr>
-          <p:cNvPr id="5" name="Placeholder 0"/>
+          <p:cNvPr id="3" name="Placeholder 0"/>
           <p:cNvSpPr txBox="1"/>
           <p:nvPr>
             <p:ph type="title" idx="0"/>
@@ -5428,7 +4576,7 @@
       </p:sp>
       <p:sp>
         <p:nvSpPr>
-          <p:cNvPr id="6" name="Placeholder 1"/>
+          <p:cNvPr id="4" name="Placeholder 1"/>
           <p:cNvSpPr txBox="1"/>
           <p:nvPr>
             <p:ph type="body" idx="1"/>
@@ -5473,7 +4621,7 @@
       </p:sp>
       <p:sp>
         <p:nvSpPr>
-          <p:cNvPr id="7" name="Placeholder 2"/>
+          <p:cNvPr id="5" name="Placeholder 2"/>
           <p:cNvSpPr txBox="1"/>
           <p:nvPr>
             <p:ph type="body" idx="2"/>
@@ -5538,7 +4686,7 @@
       </p:sp>
       <p:sp>
         <p:nvSpPr>
-          <p:cNvPr id="8" name="Placeholder 3"/>
+          <p:cNvPr id="6" name="Placeholder 3"/>
           <p:cNvSpPr txBox="1"/>
           <p:nvPr>
             <p:ph type="body" idx="3"/>
@@ -5583,7 +4731,7 @@
       </p:sp>
       <p:sp>
         <p:nvSpPr>
-          <p:cNvPr id="9" name="Placeholder 4"/>
+          <p:cNvPr id="7" name="Placeholder 4"/>
           <p:cNvSpPr txBox="1"/>
           <p:nvPr>
             <p:ph type="body" idx="4"/>
@@ -5648,7 +4796,7 @@
       </p:sp>
       <p:sp>
         <p:nvSpPr>
-          <p:cNvPr id="10" name="Placeholder 5"/>
+          <p:cNvPr id="8" name="Placeholder 5"/>
           <p:cNvSpPr txBox="1"/>
           <p:nvPr>
             <p:ph type="body" idx="5"/>
@@ -5693,7 +4841,7 @@
       </p:sp>
       <p:sp>
         <p:nvSpPr>
-          <p:cNvPr id="11" name="Placeholder 6"/>
+          <p:cNvPr id="9" name="Placeholder 6"/>
           <p:cNvSpPr txBox="1"/>
           <p:nvPr>
             <p:ph type="body" idx="6"/>
@@ -5758,7 +4906,7 @@
       </p:sp>
       <p:sp>
         <p:nvSpPr>
-          <p:cNvPr id="12" name="Placeholder 7"/>
+          <p:cNvPr id="10" name="Placeholder 7"/>
           <p:cNvSpPr txBox="1"/>
           <p:nvPr>
             <p:ph type="body" idx="7"/>
@@ -5836,6 +4984,92 @@
           <a:chExt cx="0" cy="0"/>
         </a:xfrm>
       </p:grpSpPr>
+      <p:sp>
+        <p:nvSpPr>
+          <p:cNvPr id="2" name="Shared footer / Organization"/>
+          <p:cNvSpPr txBox="1"/>
+          <p:nvPr/>
+        </p:nvSpPr>
+        <p:spPr>
+          <a:xfrm>
+            <a:off x="594360" y="6382512"/>
+            <a:ext cx="3657600" cy="228600"/>
+          </a:xfrm>
+          <a:prstGeom prst="rect">
+            <a:avLst/>
+          </a:prstGeom>
+          <a:noFill/>
+        </p:spPr>
+        <p:txBody>
+          <a:bodyPr wrap="square" lIns="0" rIns="0" tIns="0" bIns="0">
+            <a:spAutoFit/>
+          </a:bodyPr>
+          <a:lstStyle/>
+          <a:p>
+            <a:pPr algn="l" marL="0" indent="0">
+              <a:defRPr sz="1100" b="1">
+                <a:solidFill>
+                  <a:srgbClr val="FFFFFF"/>
+                </a:solidFill>
+                <a:latin typeface="Inter"/>
+              </a:defRPr>
+              <a:lnSpc>
+                <a:spcPct val="112000"/>
+              </a:lnSpc>
+              <a:spcAft>
+                <a:spcPts val="1200"/>
+              </a:spcAft>
+              <a:buNone/>
+            </a:pPr>
+            <a:r>
+              <a:t>Plan B Foundation</a:t>
+            </a:r>
+          </a:p>
+        </p:txBody>
+      </p:sp>
+      <p:sp>
+        <p:nvSpPr>
+          <p:cNvPr id="3" name="Shared footer / Tagline"/>
+          <p:cNvSpPr txBox="1"/>
+          <p:nvPr/>
+        </p:nvSpPr>
+        <p:spPr>
+          <a:xfrm>
+            <a:off x="8595360" y="6382512"/>
+            <a:ext cx="2971800" cy="228600"/>
+          </a:xfrm>
+          <a:prstGeom prst="rect">
+            <a:avLst/>
+          </a:prstGeom>
+          <a:noFill/>
+        </p:spPr>
+        <p:txBody>
+          <a:bodyPr wrap="square" lIns="0" rIns="0" tIns="0" bIns="0">
+            <a:spAutoFit/>
+          </a:bodyPr>
+          <a:lstStyle/>
+          <a:p>
+            <a:pPr algn="l" marL="0" indent="0">
+              <a:defRPr sz="1100" b="0">
+                <a:solidFill>
+                  <a:srgbClr val="FFFFFF"/>
+                </a:solidFill>
+                <a:latin typeface="Inter"/>
+              </a:defRPr>
+              <a:lnSpc>
+                <a:spcPct val="112000"/>
+              </a:lnSpc>
+              <a:spcAft>
+                <a:spcPts val="1200"/>
+              </a:spcAft>
+              <a:buNone/>
+            </a:pPr>
+            <a:r>
+              <a:t>Civic Digital Commons</a:t>
+            </a:r>
+          </a:p>
+        </p:txBody>
+      </p:sp>
     </p:spTree>
     <p:extLst>
       <p:ext uri="{BB962C8B-B14F-4D97-AF65-F5344CB8AC3E}">
@@ -6130,7 +5364,7 @@
       <p:grpSpPr/>
       <p:sp>
         <p:nvSpPr>
-          <p:cNvPr id="5" name="Placeholder 0"/>
+          <p:cNvPr id="3" name="Placeholder 0"/>
           <p:cNvSpPr txBox="1"/>
           <p:nvPr>
             <p:ph type="title" idx="0"/>
@@ -6195,7 +5429,7 @@
       </p:sp>
       <p:sp>
         <p:nvSpPr>
-          <p:cNvPr id="6" name="Placeholder 1"/>
+          <p:cNvPr id="4" name="Placeholder 1"/>
           <p:cNvSpPr txBox="1"/>
           <p:nvPr>
             <p:ph type="subTitle" idx="1"/>
@@ -6240,7 +5474,7 @@
       </p:sp>
       <p:sp>
         <p:nvSpPr>
-          <p:cNvPr id="7" name="Placeholder 2"/>
+          <p:cNvPr id="5" name="Placeholder 2"/>
           <p:cNvSpPr txBox="1"/>
           <p:nvPr>
             <p:ph type="body" idx="2"/>
@@ -6300,6 +5534,211 @@
             <a:r>
               <a:t>[Event · date]</a:t>
             </a:r>
+          </a:p>
+        </p:txBody>
+      </p:sp>
+      <p:sp>
+        <p:nvSpPr>
+          <p:cNvPr id="6" name="Cover / Background panel"/>
+          <p:cNvSpPr/>
+          <p:nvPr/>
+        </p:nvSpPr>
+        <p:spPr>
+          <a:xfrm>
+            <a:off x="7818120" y="0"/>
+            <a:ext cx="4379976" cy="6080760"/>
+          </a:xfrm>
+          <a:prstGeom prst="rect">
+            <a:avLst/>
+          </a:prstGeom>
+          <a:solidFill>
+            <a:srgbClr val="211D1D"/>
+          </a:solidFill>
+          <a:ln>
+            <a:noFill/>
+          </a:ln>
+          <a:effectLst/>
+        </p:spPr>
+        <p:txBody>
+          <a:bodyPr rtlCol="0" anchor="ctr"/>
+          <a:lstStyle/>
+          <a:p>
+            <a:pPr algn="ctr"/>
+          </a:p>
+        </p:txBody>
+      </p:sp>
+      <p:pic>
+        <p:nvPicPr>
+          <p:cNvPr id="7" name="Logo / Wide / White (SVG)" descr="Lugano's Plan B original logo; existing mark, not a new Foundation logo"/>
+          <p:cNvPicPr>
+            <a:picLocks noChangeAspect="1"/>
+          </p:cNvPicPr>
+          <p:nvPr/>
+        </p:nvPicPr>
+        <p:blipFill>
+          <a:blip r:embed="rId2">
+            <a:ext uri="{96DAC541-7B7A-43D3-8B79-37D633B846F1}">
+              <ns0:svgBlip xmlns:ns0="http://schemas.microsoft.com/office/drawing/2016/SVG/main" r:embed="rId3"/>
+            </a:ext>
+          </a:blip>
+          <a:stretch>
+            <a:fillRect/>
+          </a:stretch>
+        </p:blipFill>
+        <p:spPr>
+          <a:xfrm>
+            <a:off x="8302752" y="1325880"/>
+            <a:ext cx="3401568" cy="720671"/>
+          </a:xfrm>
+          <a:prstGeom prst="rect">
+            <a:avLst/>
+          </a:prstGeom>
+        </p:spPr>
+      </p:pic>
+      <p:sp>
+        <p:nvSpPr>
+          <p:cNvPr id="8" name="Cover / Editable values"/>
+          <p:cNvSpPr txBox="1"/>
+          <p:nvPr/>
+        </p:nvSpPr>
+        <p:spPr>
+          <a:xfrm>
+            <a:off x="8302752" y="2788920"/>
+            <a:ext cx="3291840" cy="2103120"/>
+          </a:xfrm>
+          <a:prstGeom prst="rect">
+            <a:avLst/>
+          </a:prstGeom>
+          <a:noFill/>
+        </p:spPr>
+        <p:txBody>
+          <a:bodyPr wrap="square" lIns="0" rIns="0" tIns="0" bIns="0">
+            <a:spAutoFit/>
+          </a:bodyPr>
+          <a:lstStyle/>
+          <a:p>
+            <a:pPr algn="l" marL="0" indent="0">
+              <a:defRPr sz="2900" b="1">
+                <a:solidFill>
+                  <a:srgbClr val="FFFFFF"/>
+                </a:solidFill>
+                <a:latin typeface="Inter"/>
+              </a:defRPr>
+              <a:lnSpc>
+                <a:spcPct val="112000"/>
+              </a:lnSpc>
+              <a:spcAft>
+                <a:spcPts val="1200"/>
+              </a:spcAft>
+              <a:buNone/>
+            </a:pPr>
+            <a:r>
+              <a:t>Open.</a:t>
+            </a:r>
+          </a:p>
+          <a:p>
+            <a:pPr algn="l" marL="0" indent="0">
+              <a:defRPr sz="2900" b="1">
+                <a:solidFill>
+                  <a:srgbClr val="FFFFFF"/>
+                </a:solidFill>
+                <a:latin typeface="Inter"/>
+              </a:defRPr>
+              <a:lnSpc>
+                <a:spcPct val="112000"/>
+              </a:lnSpc>
+              <a:spcAft>
+                <a:spcPts val="1200"/>
+              </a:spcAft>
+              <a:buNone/>
+            </a:pPr>
+            <a:r>
+              <a:t>Capable.</a:t>
+            </a:r>
+          </a:p>
+          <a:p>
+            <a:pPr algn="l" marL="0" indent="0">
+              <a:defRPr sz="2900" b="1">
+                <a:solidFill>
+                  <a:srgbClr val="FFFFFF"/>
+                </a:solidFill>
+                <a:latin typeface="Inter"/>
+              </a:defRPr>
+              <a:lnSpc>
+                <a:spcPct val="112000"/>
+              </a:lnSpc>
+              <a:spcAft>
+                <a:spcPts val="1200"/>
+              </a:spcAft>
+              <a:buNone/>
+            </a:pPr>
+            <a:r>
+              <a:t>Curious.</a:t>
+            </a:r>
+          </a:p>
+          <a:p>
+            <a:pPr algn="l" marL="0" indent="0">
+              <a:defRPr sz="2900" b="1">
+                <a:solidFill>
+                  <a:srgbClr val="FFFFFF"/>
+                </a:solidFill>
+                <a:latin typeface="Inter"/>
+              </a:defRPr>
+              <a:lnSpc>
+                <a:spcPct val="112000"/>
+              </a:lnSpc>
+              <a:spcAft>
+                <a:spcPts val="1200"/>
+              </a:spcAft>
+              <a:buNone/>
+            </a:pPr>
+            <a:r>
+              <a:t>Grounded.</a:t>
+            </a:r>
+          </a:p>
+        </p:txBody>
+      </p:sp>
+      <p:sp>
+        <p:nvSpPr>
+          <p:cNvPr id="9" name="Cover / Movable gradient"/>
+          <p:cNvSpPr/>
+          <p:nvPr/>
+        </p:nvSpPr>
+        <p:spPr>
+          <a:xfrm>
+            <a:off x="7818120" y="0"/>
+            <a:ext cx="4379976" cy="365760"/>
+          </a:xfrm>
+          <a:prstGeom prst="rect">
+            <a:avLst/>
+          </a:prstGeom>
+          <a:gradFill rotWithShape="1">
+            <a:gsLst>
+              <a:gs pos="0">
+                <a:srgbClr val="F7931A"/>
+              </a:gs>
+              <a:gs pos="34000">
+                <a:srgbClr val="FF5DB1"/>
+              </a:gs>
+              <a:gs pos="68000">
+                <a:srgbClr val="7468FF"/>
+              </a:gs>
+              <a:gs pos="100000">
+                <a:srgbClr val="23F5FF"/>
+              </a:gs>
+            </a:gsLst>
+            <a:lin ang="0" scaled="1"/>
+          </a:gradFill>
+          <a:ln>
+            <a:noFill/>
+          </a:ln>
+          <a:effectLst/>
+        </p:spPr>
+        <p:txBody>
+          <a:bodyPr rtlCol="0" anchor="ctr"/>
+          <a:lstStyle/>
+          <a:p>
+            <a:pPr algn="ctr"/>
           </a:p>
         </p:txBody>
       </p:sp>
@@ -6331,7 +5770,7 @@
       <p:grpSpPr/>
       <p:sp>
         <p:nvSpPr>
-          <p:cNvPr id="5" name="Placeholder 0"/>
+          <p:cNvPr id="3" name="Placeholder 0"/>
           <p:cNvSpPr txBox="1"/>
           <p:nvPr>
             <p:ph type="title" idx="0"/>
@@ -6376,7 +5815,7 @@
       </p:sp>
       <p:sp>
         <p:nvSpPr>
-          <p:cNvPr id="6" name="Placeholder 1"/>
+          <p:cNvPr id="4" name="Placeholder 1"/>
           <p:cNvSpPr txBox="1"/>
           <p:nvPr>
             <p:ph type="body" idx="1"/>
@@ -6421,7 +5860,7 @@
       </p:sp>
       <p:sp>
         <p:nvSpPr>
-          <p:cNvPr id="7" name="Placeholder 2"/>
+          <p:cNvPr id="5" name="Placeholder 2"/>
           <p:cNvSpPr txBox="1"/>
           <p:nvPr>
             <p:ph type="body" idx="2"/>
@@ -6459,7 +5898,7 @@
               <a:buNone/>
             </a:pPr>
             <a:r>
-              <a:t>Use the layouts</a:t>
+              <a:t>Edit the slide</a:t>
             </a:r>
           </a:p>
           <a:p>
@@ -6479,14 +5918,14 @@
               <a:buNone/>
             </a:pPr>
             <a:r>
-              <a:t>Install Inter, then choose Home → New Slide. Replace bracketed prompts. Duplicate the chart or table example to retain its styling.</a:t>
-            </a:r>
-          </a:p>
-        </p:txBody>
-      </p:sp>
-      <p:sp>
-        <p:nvSpPr>
-          <p:cNvPr id="8" name="Placeholder 3"/>
+              <a:t>Duplicate the cover to keep its movable SVG logo, text, panel and top gradient. Copy other logo forms from the library slides. Use New Slide for content layouts.</a:t>
+            </a:r>
+          </a:p>
+        </p:txBody>
+      </p:sp>
+      <p:sp>
+        <p:nvSpPr>
+          <p:cNvPr id="6" name="Placeholder 3"/>
           <p:cNvSpPr txBox="1"/>
           <p:nvPr>
             <p:ph type="body" idx="3"/>
@@ -6524,7 +5963,7 @@
               <a:buNone/>
             </a:pPr>
             <a:r>
-              <a:t>Keep it clear</a:t>
+              <a:t>Edit every footer at once</a:t>
             </a:r>
           </a:p>
           <a:p>
@@ -6544,11 +5983,1244 @@
               <a:buNone/>
             </a:pPr>
             <a:r>
-              <a:t>One idea per slide. Keep the selected light or dark palette. Preserve the gradient band and keep text on solid grounds. Aim for 20pt or larger body text.</a:t>
-            </a:r>
-          </a:p>
-        </p:txBody>
-      </p:sp>
+              <a:t>View → Slide Master → select the top parent master. Edit the two footer text boxes, then Close Master View. Delete this guide and the logo library before presenting.</a:t>
+            </a:r>
+          </a:p>
+        </p:txBody>
+      </p:sp>
+    </p:spTree>
+  </p:cSld>
+  <p:clrMapOvr>
+    <a:masterClrMapping/>
+  </p:clrMapOvr>
+</p:sld>
+</file>
+
+<file path=ppt/slides/slide11.xml><?xml version="1.0" encoding="utf-8"?>
+<p:sld xmlns:a="http://schemas.openxmlformats.org/drawingml/2006/main" xmlns:p="http://schemas.openxmlformats.org/presentationml/2006/main" xmlns:r="http://schemas.openxmlformats.org/officeDocument/2006/relationships" showMasterSp="1">
+  <p:cSld>
+    <p:spTree>
+      <p:nvGrpSpPr>
+        <p:cNvPr id="1" name=""/>
+        <p:cNvGrpSpPr/>
+        <p:nvPr/>
+      </p:nvGrpSpPr>
+      <p:grpSpPr/>
+      <p:sp>
+        <p:nvSpPr>
+          <p:cNvPr id="2" name="Placeholder 0"/>
+          <p:cNvSpPr txBox="1"/>
+          <p:nvPr>
+            <p:ph type="title" idx="0"/>
+          </p:nvPr>
+        </p:nvSpPr>
+        <p:spPr>
+          <a:xfrm>
+            <a:off x="594360" y="502920"/>
+            <a:ext cx="10972800" cy="1005840"/>
+          </a:xfrm>
+          <a:prstGeom prst="rect">
+            <a:avLst/>
+          </a:prstGeom>
+          <a:noFill/>
+        </p:spPr>
+        <p:txBody>
+          <a:bodyPr wrap="square" lIns="0" rIns="0" tIns="0" bIns="0">
+            <a:spAutoFit/>
+          </a:bodyPr>
+          <a:lstStyle/>
+          <a:p>
+            <a:pPr algn="l" marL="0" indent="0">
+              <a:defRPr sz="3600" b="1">
+                <a:solidFill>
+                  <a:srgbClr val="FFFFFF"/>
+                </a:solidFill>
+                <a:latin typeface="Inter"/>
+              </a:defRPr>
+              <a:lnSpc>
+                <a:spcPct val="112000"/>
+              </a:lnSpc>
+              <a:spcAft>
+                <a:spcPts val="1200"/>
+              </a:spcAft>
+              <a:buNone/>
+            </a:pPr>
+            <a:r>
+              <a:t>Logo library / Color</a:t>
+            </a:r>
+          </a:p>
+        </p:txBody>
+      </p:sp>
+      <p:sp>
+        <p:nvSpPr>
+          <p:cNvPr id="3" name="Placeholder 1"/>
+          <p:cNvSpPr txBox="1"/>
+          <p:nvPr>
+            <p:ph type="body" idx="1"/>
+          </p:nvPr>
+        </p:nvSpPr>
+        <p:spPr>
+          <a:xfrm>
+            <a:off x="594360" y="1508760"/>
+            <a:ext cx="10698480" cy="685800"/>
+          </a:xfrm>
+          <a:prstGeom prst="rect">
+            <a:avLst/>
+          </a:prstGeom>
+          <a:noFill/>
+        </p:spPr>
+        <p:txBody>
+          <a:bodyPr wrap="square" lIns="0" rIns="0" tIns="0" bIns="0">
+            <a:spAutoFit/>
+          </a:bodyPr>
+          <a:lstStyle/>
+          <a:p>
+            <a:pPr algn="l" marL="0" indent="0">
+              <a:defRPr sz="1900" b="0">
+                <a:solidFill>
+                  <a:srgbClr val="FFFFFF"/>
+                </a:solidFill>
+                <a:latin typeface="Inter"/>
+              </a:defRPr>
+              <a:lnSpc>
+                <a:spcPct val="112000"/>
+              </a:lnSpc>
+              <a:spcAft>
+                <a:spcPts val="1200"/>
+              </a:spcAft>
+              <a:buNone/>
+            </a:pPr>
+            <a:r>
+              <a:t>Select a logo and copy it to any slide. Delete this library before presenting.</a:t>
+            </a:r>
+          </a:p>
+        </p:txBody>
+      </p:sp>
+      <p:sp>
+        <p:nvSpPr>
+          <p:cNvPr id="4" name="Wide"/>
+          <p:cNvSpPr txBox="1"/>
+          <p:nvPr/>
+        </p:nvSpPr>
+        <p:spPr>
+          <a:xfrm>
+            <a:off x="594360" y="2194560"/>
+            <a:ext cx="3383280" cy="411480"/>
+          </a:xfrm>
+          <a:prstGeom prst="rect">
+            <a:avLst/>
+          </a:prstGeom>
+          <a:noFill/>
+        </p:spPr>
+        <p:txBody>
+          <a:bodyPr wrap="square" lIns="0" rIns="0" tIns="0" bIns="0">
+            <a:spAutoFit/>
+          </a:bodyPr>
+          <a:lstStyle/>
+          <a:p>
+            <a:pPr algn="l" marL="0" indent="0">
+              <a:defRPr sz="2300" b="1">
+                <a:solidFill>
+                  <a:srgbClr val="FFFFFF"/>
+                </a:solidFill>
+                <a:latin typeface="Inter"/>
+              </a:defRPr>
+              <a:lnSpc>
+                <a:spcPct val="112000"/>
+              </a:lnSpc>
+              <a:spcAft>
+                <a:spcPts val="1200"/>
+              </a:spcAft>
+              <a:buNone/>
+            </a:pPr>
+            <a:r>
+              <a:t>Wide</a:t>
+            </a:r>
+          </a:p>
+        </p:txBody>
+      </p:sp>
+      <p:sp>
+        <p:nvSpPr>
+          <p:cNvPr id="5" name="Logo ground / wide"/>
+          <p:cNvSpPr/>
+          <p:nvPr/>
+        </p:nvSpPr>
+        <p:spPr>
+          <a:xfrm>
+            <a:off x="594360" y="2743200"/>
+            <a:ext cx="3383280" cy="2971800"/>
+          </a:xfrm>
+          <a:prstGeom prst="rect">
+            <a:avLst/>
+          </a:prstGeom>
+          <a:solidFill>
+            <a:srgbClr val="082952"/>
+          </a:solidFill>
+          <a:ln>
+            <a:noFill/>
+          </a:ln>
+          <a:effectLst/>
+        </p:spPr>
+        <p:txBody>
+          <a:bodyPr rtlCol="0" anchor="ctr"/>
+          <a:lstStyle/>
+          <a:p>
+            <a:pPr algn="ctr"/>
+          </a:p>
+        </p:txBody>
+      </p:sp>
+      <p:pic>
+        <p:nvPicPr>
+          <p:cNvPr id="6" name="Logo / Wide / Color (SVG)" descr="Lugano's Plan B original logo; existing mark, not a new Foundation logo"/>
+          <p:cNvPicPr>
+            <a:picLocks noChangeAspect="1"/>
+          </p:cNvPicPr>
+          <p:nvPr/>
+        </p:nvPicPr>
+        <p:blipFill>
+          <a:blip r:embed="rId2">
+            <a:ext uri="{96DAC541-7B7A-43D3-8B79-37D633B846F1}">
+              <ns0:svgBlip xmlns:ns0="http://schemas.microsoft.com/office/drawing/2016/SVG/main" r:embed="rId3"/>
+            </a:ext>
+          </a:blip>
+          <a:stretch>
+            <a:fillRect/>
+          </a:stretch>
+        </p:blipFill>
+        <p:spPr>
+          <a:xfrm>
+            <a:off x="822960" y="3850941"/>
+            <a:ext cx="2926080" cy="756317"/>
+          </a:xfrm>
+          <a:prstGeom prst="rect">
+            <a:avLst/>
+          </a:prstGeom>
+        </p:spPr>
+      </p:pic>
+      <p:sp>
+        <p:nvSpPr>
+          <p:cNvPr id="7" name="Square"/>
+          <p:cNvSpPr txBox="1"/>
+          <p:nvPr/>
+        </p:nvSpPr>
+        <p:spPr>
+          <a:xfrm>
+            <a:off x="4389120" y="2194560"/>
+            <a:ext cx="3383280" cy="411480"/>
+          </a:xfrm>
+          <a:prstGeom prst="rect">
+            <a:avLst/>
+          </a:prstGeom>
+          <a:noFill/>
+        </p:spPr>
+        <p:txBody>
+          <a:bodyPr wrap="square" lIns="0" rIns="0" tIns="0" bIns="0">
+            <a:spAutoFit/>
+          </a:bodyPr>
+          <a:lstStyle/>
+          <a:p>
+            <a:pPr algn="l" marL="0" indent="0">
+              <a:defRPr sz="2300" b="1">
+                <a:solidFill>
+                  <a:srgbClr val="FFFFFF"/>
+                </a:solidFill>
+                <a:latin typeface="Inter"/>
+              </a:defRPr>
+              <a:lnSpc>
+                <a:spcPct val="112000"/>
+              </a:lnSpc>
+              <a:spcAft>
+                <a:spcPts val="1200"/>
+              </a:spcAft>
+              <a:buNone/>
+            </a:pPr>
+            <a:r>
+              <a:t>Square</a:t>
+            </a:r>
+          </a:p>
+        </p:txBody>
+      </p:sp>
+      <p:sp>
+        <p:nvSpPr>
+          <p:cNvPr id="8" name="Logo ground / square"/>
+          <p:cNvSpPr/>
+          <p:nvPr/>
+        </p:nvSpPr>
+        <p:spPr>
+          <a:xfrm>
+            <a:off x="4389120" y="2743200"/>
+            <a:ext cx="3383280" cy="2971800"/>
+          </a:xfrm>
+          <a:prstGeom prst="rect">
+            <a:avLst/>
+          </a:prstGeom>
+          <a:solidFill>
+            <a:srgbClr val="082952"/>
+          </a:solidFill>
+          <a:ln>
+            <a:noFill/>
+          </a:ln>
+          <a:effectLst/>
+        </p:spPr>
+        <p:txBody>
+          <a:bodyPr rtlCol="0" anchor="ctr"/>
+          <a:lstStyle/>
+          <a:p>
+            <a:pPr algn="ctr"/>
+          </a:p>
+        </p:txBody>
+      </p:sp>
+      <p:pic>
+        <p:nvPicPr>
+          <p:cNvPr id="9" name="Logo / Square / Color (SVG)" descr="Lugano's Plan B original logo; existing mark, not a new Foundation logo"/>
+          <p:cNvPicPr>
+            <a:picLocks noChangeAspect="1"/>
+          </p:cNvPicPr>
+          <p:nvPr/>
+        </p:nvPicPr>
+        <p:blipFill>
+          <a:blip r:embed="rId4">
+            <a:ext uri="{96DAC541-7B7A-43D3-8B79-37D633B846F1}">
+              <ns0:svgBlip xmlns:ns0="http://schemas.microsoft.com/office/drawing/2016/SVG/main" r:embed="rId5"/>
+            </a:ext>
+          </a:blip>
+          <a:stretch>
+            <a:fillRect/>
+          </a:stretch>
+        </p:blipFill>
+        <p:spPr>
+          <a:xfrm>
+            <a:off x="4617720" y="3713523"/>
+            <a:ext cx="2926080" cy="1031154"/>
+          </a:xfrm>
+          <a:prstGeom prst="rect">
+            <a:avLst/>
+          </a:prstGeom>
+        </p:spPr>
+      </p:pic>
+      <p:sp>
+        <p:nvSpPr>
+          <p:cNvPr id="10" name="Tall"/>
+          <p:cNvSpPr txBox="1"/>
+          <p:nvPr/>
+        </p:nvSpPr>
+        <p:spPr>
+          <a:xfrm>
+            <a:off x="8183880" y="2194560"/>
+            <a:ext cx="3383280" cy="411480"/>
+          </a:xfrm>
+          <a:prstGeom prst="rect">
+            <a:avLst/>
+          </a:prstGeom>
+          <a:noFill/>
+        </p:spPr>
+        <p:txBody>
+          <a:bodyPr wrap="square" lIns="0" rIns="0" tIns="0" bIns="0">
+            <a:spAutoFit/>
+          </a:bodyPr>
+          <a:lstStyle/>
+          <a:p>
+            <a:pPr algn="l" marL="0" indent="0">
+              <a:defRPr sz="2300" b="1">
+                <a:solidFill>
+                  <a:srgbClr val="FFFFFF"/>
+                </a:solidFill>
+                <a:latin typeface="Inter"/>
+              </a:defRPr>
+              <a:lnSpc>
+                <a:spcPct val="112000"/>
+              </a:lnSpc>
+              <a:spcAft>
+                <a:spcPts val="1200"/>
+              </a:spcAft>
+              <a:buNone/>
+            </a:pPr>
+            <a:r>
+              <a:t>Tall</a:t>
+            </a:r>
+          </a:p>
+        </p:txBody>
+      </p:sp>
+      <p:sp>
+        <p:nvSpPr>
+          <p:cNvPr id="11" name="Logo ground / tall"/>
+          <p:cNvSpPr/>
+          <p:nvPr/>
+        </p:nvSpPr>
+        <p:spPr>
+          <a:xfrm>
+            <a:off x="8183880" y="2743200"/>
+            <a:ext cx="3383280" cy="2971800"/>
+          </a:xfrm>
+          <a:prstGeom prst="rect">
+            <a:avLst/>
+          </a:prstGeom>
+          <a:solidFill>
+            <a:srgbClr val="082952"/>
+          </a:solidFill>
+          <a:ln>
+            <a:noFill/>
+          </a:ln>
+          <a:effectLst/>
+        </p:spPr>
+        <p:txBody>
+          <a:bodyPr rtlCol="0" anchor="ctr"/>
+          <a:lstStyle/>
+          <a:p>
+            <a:pPr algn="ctr"/>
+          </a:p>
+        </p:txBody>
+      </p:sp>
+      <p:pic>
+        <p:nvPicPr>
+          <p:cNvPr id="12" name="Logo / Tall / Color (SVG)" descr="Lugano's Plan B original logo; existing mark, not a new Foundation logo"/>
+          <p:cNvPicPr>
+            <a:picLocks noChangeAspect="1"/>
+          </p:cNvPicPr>
+          <p:nvPr/>
+        </p:nvPicPr>
+        <p:blipFill>
+          <a:blip r:embed="rId6">
+            <a:ext uri="{96DAC541-7B7A-43D3-8B79-37D633B846F1}">
+              <ns0:svgBlip xmlns:ns0="http://schemas.microsoft.com/office/drawing/2016/SVG/main" r:embed="rId7"/>
+            </a:ext>
+          </a:blip>
+          <a:stretch>
+            <a:fillRect/>
+          </a:stretch>
+        </p:blipFill>
+        <p:spPr>
+          <a:xfrm>
+            <a:off x="9121140" y="2971800"/>
+            <a:ext cx="1508760" cy="2514600"/>
+          </a:xfrm>
+          <a:prstGeom prst="rect">
+            <a:avLst/>
+          </a:prstGeom>
+        </p:spPr>
+      </p:pic>
+    </p:spTree>
+  </p:cSld>
+  <p:clrMapOvr>
+    <a:masterClrMapping/>
+  </p:clrMapOvr>
+</p:sld>
+</file>
+
+<file path=ppt/slides/slide12.xml><?xml version="1.0" encoding="utf-8"?>
+<p:sld xmlns:a="http://schemas.openxmlformats.org/drawingml/2006/main" xmlns:p="http://schemas.openxmlformats.org/presentationml/2006/main" xmlns:r="http://schemas.openxmlformats.org/officeDocument/2006/relationships" showMasterSp="1">
+  <p:cSld>
+    <p:spTree>
+      <p:nvGrpSpPr>
+        <p:cNvPr id="1" name=""/>
+        <p:cNvGrpSpPr/>
+        <p:nvPr/>
+      </p:nvGrpSpPr>
+      <p:grpSpPr/>
+      <p:sp>
+        <p:nvSpPr>
+          <p:cNvPr id="2" name="Placeholder 0"/>
+          <p:cNvSpPr txBox="1"/>
+          <p:nvPr>
+            <p:ph type="title" idx="0"/>
+          </p:nvPr>
+        </p:nvSpPr>
+        <p:spPr>
+          <a:xfrm>
+            <a:off x="594360" y="502920"/>
+            <a:ext cx="10972800" cy="1005840"/>
+          </a:xfrm>
+          <a:prstGeom prst="rect">
+            <a:avLst/>
+          </a:prstGeom>
+          <a:noFill/>
+        </p:spPr>
+        <p:txBody>
+          <a:bodyPr wrap="square" lIns="0" rIns="0" tIns="0" bIns="0">
+            <a:spAutoFit/>
+          </a:bodyPr>
+          <a:lstStyle/>
+          <a:p>
+            <a:pPr algn="l" marL="0" indent="0">
+              <a:defRPr sz="3600" b="1">
+                <a:solidFill>
+                  <a:srgbClr val="FFFFFF"/>
+                </a:solidFill>
+                <a:latin typeface="Inter"/>
+              </a:defRPr>
+              <a:lnSpc>
+                <a:spcPct val="112000"/>
+              </a:lnSpc>
+              <a:spcAft>
+                <a:spcPts val="1200"/>
+              </a:spcAft>
+              <a:buNone/>
+            </a:pPr>
+            <a:r>
+              <a:t>Logo library / Black</a:t>
+            </a:r>
+          </a:p>
+        </p:txBody>
+      </p:sp>
+      <p:sp>
+        <p:nvSpPr>
+          <p:cNvPr id="3" name="Placeholder 1"/>
+          <p:cNvSpPr txBox="1"/>
+          <p:nvPr>
+            <p:ph type="body" idx="1"/>
+          </p:nvPr>
+        </p:nvSpPr>
+        <p:spPr>
+          <a:xfrm>
+            <a:off x="594360" y="1508760"/>
+            <a:ext cx="10698480" cy="685800"/>
+          </a:xfrm>
+          <a:prstGeom prst="rect">
+            <a:avLst/>
+          </a:prstGeom>
+          <a:noFill/>
+        </p:spPr>
+        <p:txBody>
+          <a:bodyPr wrap="square" lIns="0" rIns="0" tIns="0" bIns="0">
+            <a:spAutoFit/>
+          </a:bodyPr>
+          <a:lstStyle/>
+          <a:p>
+            <a:pPr algn="l" marL="0" indent="0">
+              <a:defRPr sz="1900" b="0">
+                <a:solidFill>
+                  <a:srgbClr val="FFFFFF"/>
+                </a:solidFill>
+                <a:latin typeface="Inter"/>
+              </a:defRPr>
+              <a:lnSpc>
+                <a:spcPct val="112000"/>
+              </a:lnSpc>
+              <a:spcAft>
+                <a:spcPts val="1200"/>
+              </a:spcAft>
+              <a:buNone/>
+            </a:pPr>
+            <a:r>
+              <a:t>Select a logo and copy it to any slide. Delete this library before presenting.</a:t>
+            </a:r>
+          </a:p>
+        </p:txBody>
+      </p:sp>
+      <p:sp>
+        <p:nvSpPr>
+          <p:cNvPr id="4" name="Wide"/>
+          <p:cNvSpPr txBox="1"/>
+          <p:nvPr/>
+        </p:nvSpPr>
+        <p:spPr>
+          <a:xfrm>
+            <a:off x="594360" y="2194560"/>
+            <a:ext cx="3383280" cy="411480"/>
+          </a:xfrm>
+          <a:prstGeom prst="rect">
+            <a:avLst/>
+          </a:prstGeom>
+          <a:noFill/>
+        </p:spPr>
+        <p:txBody>
+          <a:bodyPr wrap="square" lIns="0" rIns="0" tIns="0" bIns="0">
+            <a:spAutoFit/>
+          </a:bodyPr>
+          <a:lstStyle/>
+          <a:p>
+            <a:pPr algn="l" marL="0" indent="0">
+              <a:defRPr sz="2300" b="1">
+                <a:solidFill>
+                  <a:srgbClr val="FFFFFF"/>
+                </a:solidFill>
+                <a:latin typeface="Inter"/>
+              </a:defRPr>
+              <a:lnSpc>
+                <a:spcPct val="112000"/>
+              </a:lnSpc>
+              <a:spcAft>
+                <a:spcPts val="1200"/>
+              </a:spcAft>
+              <a:buNone/>
+            </a:pPr>
+            <a:r>
+              <a:t>Wide</a:t>
+            </a:r>
+          </a:p>
+        </p:txBody>
+      </p:sp>
+      <p:sp>
+        <p:nvSpPr>
+          <p:cNvPr id="5" name="Logo ground / wide"/>
+          <p:cNvSpPr/>
+          <p:nvPr/>
+        </p:nvSpPr>
+        <p:spPr>
+          <a:xfrm>
+            <a:off x="594360" y="2743200"/>
+            <a:ext cx="3383280" cy="2971800"/>
+          </a:xfrm>
+          <a:prstGeom prst="rect">
+            <a:avLst/>
+          </a:prstGeom>
+          <a:solidFill>
+            <a:srgbClr val="FFFEFA"/>
+          </a:solidFill>
+          <a:ln>
+            <a:noFill/>
+          </a:ln>
+          <a:effectLst/>
+        </p:spPr>
+        <p:txBody>
+          <a:bodyPr rtlCol="0" anchor="ctr"/>
+          <a:lstStyle/>
+          <a:p>
+            <a:pPr algn="ctr"/>
+          </a:p>
+        </p:txBody>
+      </p:sp>
+      <p:pic>
+        <p:nvPicPr>
+          <p:cNvPr id="6" name="Logo / Wide / Black (SVG)" descr="Lugano's Plan B original logo; existing mark, not a new Foundation logo"/>
+          <p:cNvPicPr>
+            <a:picLocks noChangeAspect="1"/>
+          </p:cNvPicPr>
+          <p:nvPr/>
+        </p:nvPicPr>
+        <p:blipFill>
+          <a:blip r:embed="rId2">
+            <a:ext uri="{96DAC541-7B7A-43D3-8B79-37D633B846F1}">
+              <ns0:svgBlip xmlns:ns0="http://schemas.microsoft.com/office/drawing/2016/SVG/main" r:embed="rId3"/>
+            </a:ext>
+          </a:blip>
+          <a:stretch>
+            <a:fillRect/>
+          </a:stretch>
+        </p:blipFill>
+        <p:spPr>
+          <a:xfrm>
+            <a:off x="822960" y="3850941"/>
+            <a:ext cx="2926080" cy="756317"/>
+          </a:xfrm>
+          <a:prstGeom prst="rect">
+            <a:avLst/>
+          </a:prstGeom>
+        </p:spPr>
+      </p:pic>
+      <p:sp>
+        <p:nvSpPr>
+          <p:cNvPr id="7" name="Square"/>
+          <p:cNvSpPr txBox="1"/>
+          <p:nvPr/>
+        </p:nvSpPr>
+        <p:spPr>
+          <a:xfrm>
+            <a:off x="4389120" y="2194560"/>
+            <a:ext cx="3383280" cy="411480"/>
+          </a:xfrm>
+          <a:prstGeom prst="rect">
+            <a:avLst/>
+          </a:prstGeom>
+          <a:noFill/>
+        </p:spPr>
+        <p:txBody>
+          <a:bodyPr wrap="square" lIns="0" rIns="0" tIns="0" bIns="0">
+            <a:spAutoFit/>
+          </a:bodyPr>
+          <a:lstStyle/>
+          <a:p>
+            <a:pPr algn="l" marL="0" indent="0">
+              <a:defRPr sz="2300" b="1">
+                <a:solidFill>
+                  <a:srgbClr val="FFFFFF"/>
+                </a:solidFill>
+                <a:latin typeface="Inter"/>
+              </a:defRPr>
+              <a:lnSpc>
+                <a:spcPct val="112000"/>
+              </a:lnSpc>
+              <a:spcAft>
+                <a:spcPts val="1200"/>
+              </a:spcAft>
+              <a:buNone/>
+            </a:pPr>
+            <a:r>
+              <a:t>Square</a:t>
+            </a:r>
+          </a:p>
+        </p:txBody>
+      </p:sp>
+      <p:sp>
+        <p:nvSpPr>
+          <p:cNvPr id="8" name="Logo ground / square"/>
+          <p:cNvSpPr/>
+          <p:nvPr/>
+        </p:nvSpPr>
+        <p:spPr>
+          <a:xfrm>
+            <a:off x="4389120" y="2743200"/>
+            <a:ext cx="3383280" cy="2971800"/>
+          </a:xfrm>
+          <a:prstGeom prst="rect">
+            <a:avLst/>
+          </a:prstGeom>
+          <a:solidFill>
+            <a:srgbClr val="FFFEFA"/>
+          </a:solidFill>
+          <a:ln>
+            <a:noFill/>
+          </a:ln>
+          <a:effectLst/>
+        </p:spPr>
+        <p:txBody>
+          <a:bodyPr rtlCol="0" anchor="ctr"/>
+          <a:lstStyle/>
+          <a:p>
+            <a:pPr algn="ctr"/>
+          </a:p>
+        </p:txBody>
+      </p:sp>
+      <p:pic>
+        <p:nvPicPr>
+          <p:cNvPr id="9" name="Logo / Square / Black (SVG)" descr="Lugano's Plan B original logo; existing mark, not a new Foundation logo"/>
+          <p:cNvPicPr>
+            <a:picLocks noChangeAspect="1"/>
+          </p:cNvPicPr>
+          <p:nvPr/>
+        </p:nvPicPr>
+        <p:blipFill>
+          <a:blip r:embed="rId4">
+            <a:ext uri="{96DAC541-7B7A-43D3-8B79-37D633B846F1}">
+              <ns0:svgBlip xmlns:ns0="http://schemas.microsoft.com/office/drawing/2016/SVG/main" r:embed="rId5"/>
+            </a:ext>
+          </a:blip>
+          <a:stretch>
+            <a:fillRect/>
+          </a:stretch>
+        </p:blipFill>
+        <p:spPr>
+          <a:xfrm>
+            <a:off x="4617720" y="3713523"/>
+            <a:ext cx="2926080" cy="1031154"/>
+          </a:xfrm>
+          <a:prstGeom prst="rect">
+            <a:avLst/>
+          </a:prstGeom>
+        </p:spPr>
+      </p:pic>
+      <p:sp>
+        <p:nvSpPr>
+          <p:cNvPr id="10" name="Tall"/>
+          <p:cNvSpPr txBox="1"/>
+          <p:nvPr/>
+        </p:nvSpPr>
+        <p:spPr>
+          <a:xfrm>
+            <a:off x="8183880" y="2194560"/>
+            <a:ext cx="3383280" cy="411480"/>
+          </a:xfrm>
+          <a:prstGeom prst="rect">
+            <a:avLst/>
+          </a:prstGeom>
+          <a:noFill/>
+        </p:spPr>
+        <p:txBody>
+          <a:bodyPr wrap="square" lIns="0" rIns="0" tIns="0" bIns="0">
+            <a:spAutoFit/>
+          </a:bodyPr>
+          <a:lstStyle/>
+          <a:p>
+            <a:pPr algn="l" marL="0" indent="0">
+              <a:defRPr sz="2300" b="1">
+                <a:solidFill>
+                  <a:srgbClr val="FFFFFF"/>
+                </a:solidFill>
+                <a:latin typeface="Inter"/>
+              </a:defRPr>
+              <a:lnSpc>
+                <a:spcPct val="112000"/>
+              </a:lnSpc>
+              <a:spcAft>
+                <a:spcPts val="1200"/>
+              </a:spcAft>
+              <a:buNone/>
+            </a:pPr>
+            <a:r>
+              <a:t>Tall</a:t>
+            </a:r>
+          </a:p>
+        </p:txBody>
+      </p:sp>
+      <p:sp>
+        <p:nvSpPr>
+          <p:cNvPr id="11" name="Logo ground / tall"/>
+          <p:cNvSpPr/>
+          <p:nvPr/>
+        </p:nvSpPr>
+        <p:spPr>
+          <a:xfrm>
+            <a:off x="8183880" y="2743200"/>
+            <a:ext cx="3383280" cy="2971800"/>
+          </a:xfrm>
+          <a:prstGeom prst="rect">
+            <a:avLst/>
+          </a:prstGeom>
+          <a:solidFill>
+            <a:srgbClr val="FFFEFA"/>
+          </a:solidFill>
+          <a:ln>
+            <a:noFill/>
+          </a:ln>
+          <a:effectLst/>
+        </p:spPr>
+        <p:txBody>
+          <a:bodyPr rtlCol="0" anchor="ctr"/>
+          <a:lstStyle/>
+          <a:p>
+            <a:pPr algn="ctr"/>
+          </a:p>
+        </p:txBody>
+      </p:sp>
+      <p:pic>
+        <p:nvPicPr>
+          <p:cNvPr id="12" name="Logo / Tall / Black (SVG)" descr="Lugano's Plan B original logo; existing mark, not a new Foundation logo"/>
+          <p:cNvPicPr>
+            <a:picLocks noChangeAspect="1"/>
+          </p:cNvPicPr>
+          <p:nvPr/>
+        </p:nvPicPr>
+        <p:blipFill>
+          <a:blip r:embed="rId6">
+            <a:ext uri="{96DAC541-7B7A-43D3-8B79-37D633B846F1}">
+              <ns0:svgBlip xmlns:ns0="http://schemas.microsoft.com/office/drawing/2016/SVG/main" r:embed="rId7"/>
+            </a:ext>
+          </a:blip>
+          <a:stretch>
+            <a:fillRect/>
+          </a:stretch>
+        </p:blipFill>
+        <p:spPr>
+          <a:xfrm>
+            <a:off x="9121140" y="2971800"/>
+            <a:ext cx="1508760" cy="2514600"/>
+          </a:xfrm>
+          <a:prstGeom prst="rect">
+            <a:avLst/>
+          </a:prstGeom>
+        </p:spPr>
+      </p:pic>
+    </p:spTree>
+  </p:cSld>
+  <p:clrMapOvr>
+    <a:masterClrMapping/>
+  </p:clrMapOvr>
+</p:sld>
+</file>
+
+<file path=ppt/slides/slide13.xml><?xml version="1.0" encoding="utf-8"?>
+<p:sld xmlns:a="http://schemas.openxmlformats.org/drawingml/2006/main" xmlns:p="http://schemas.openxmlformats.org/presentationml/2006/main" xmlns:r="http://schemas.openxmlformats.org/officeDocument/2006/relationships" showMasterSp="1">
+  <p:cSld>
+    <p:spTree>
+      <p:nvGrpSpPr>
+        <p:cNvPr id="1" name=""/>
+        <p:cNvGrpSpPr/>
+        <p:nvPr/>
+      </p:nvGrpSpPr>
+      <p:grpSpPr/>
+      <p:sp>
+        <p:nvSpPr>
+          <p:cNvPr id="2" name="Placeholder 0"/>
+          <p:cNvSpPr txBox="1"/>
+          <p:nvPr>
+            <p:ph type="title" idx="0"/>
+          </p:nvPr>
+        </p:nvSpPr>
+        <p:spPr>
+          <a:xfrm>
+            <a:off x="594360" y="502920"/>
+            <a:ext cx="10972800" cy="1005840"/>
+          </a:xfrm>
+          <a:prstGeom prst="rect">
+            <a:avLst/>
+          </a:prstGeom>
+          <a:noFill/>
+        </p:spPr>
+        <p:txBody>
+          <a:bodyPr wrap="square" lIns="0" rIns="0" tIns="0" bIns="0">
+            <a:spAutoFit/>
+          </a:bodyPr>
+          <a:lstStyle/>
+          <a:p>
+            <a:pPr algn="l" marL="0" indent="0">
+              <a:defRPr sz="3600" b="1">
+                <a:solidFill>
+                  <a:srgbClr val="FFFFFF"/>
+                </a:solidFill>
+                <a:latin typeface="Inter"/>
+              </a:defRPr>
+              <a:lnSpc>
+                <a:spcPct val="112000"/>
+              </a:lnSpc>
+              <a:spcAft>
+                <a:spcPts val="1200"/>
+              </a:spcAft>
+              <a:buNone/>
+            </a:pPr>
+            <a:r>
+              <a:t>Logo library / White</a:t>
+            </a:r>
+          </a:p>
+        </p:txBody>
+      </p:sp>
+      <p:sp>
+        <p:nvSpPr>
+          <p:cNvPr id="3" name="Placeholder 1"/>
+          <p:cNvSpPr txBox="1"/>
+          <p:nvPr>
+            <p:ph type="body" idx="1"/>
+          </p:nvPr>
+        </p:nvSpPr>
+        <p:spPr>
+          <a:xfrm>
+            <a:off x="594360" y="1508760"/>
+            <a:ext cx="10698480" cy="685800"/>
+          </a:xfrm>
+          <a:prstGeom prst="rect">
+            <a:avLst/>
+          </a:prstGeom>
+          <a:noFill/>
+        </p:spPr>
+        <p:txBody>
+          <a:bodyPr wrap="square" lIns="0" rIns="0" tIns="0" bIns="0">
+            <a:spAutoFit/>
+          </a:bodyPr>
+          <a:lstStyle/>
+          <a:p>
+            <a:pPr algn="l" marL="0" indent="0">
+              <a:defRPr sz="1900" b="0">
+                <a:solidFill>
+                  <a:srgbClr val="FFFFFF"/>
+                </a:solidFill>
+                <a:latin typeface="Inter"/>
+              </a:defRPr>
+              <a:lnSpc>
+                <a:spcPct val="112000"/>
+              </a:lnSpc>
+              <a:spcAft>
+                <a:spcPts val="1200"/>
+              </a:spcAft>
+              <a:buNone/>
+            </a:pPr>
+            <a:r>
+              <a:t>Select a logo and copy it to any slide. Delete this library before presenting.</a:t>
+            </a:r>
+          </a:p>
+        </p:txBody>
+      </p:sp>
+      <p:sp>
+        <p:nvSpPr>
+          <p:cNvPr id="4" name="Wide"/>
+          <p:cNvSpPr txBox="1"/>
+          <p:nvPr/>
+        </p:nvSpPr>
+        <p:spPr>
+          <a:xfrm>
+            <a:off x="594360" y="2194560"/>
+            <a:ext cx="3383280" cy="411480"/>
+          </a:xfrm>
+          <a:prstGeom prst="rect">
+            <a:avLst/>
+          </a:prstGeom>
+          <a:noFill/>
+        </p:spPr>
+        <p:txBody>
+          <a:bodyPr wrap="square" lIns="0" rIns="0" tIns="0" bIns="0">
+            <a:spAutoFit/>
+          </a:bodyPr>
+          <a:lstStyle/>
+          <a:p>
+            <a:pPr algn="l" marL="0" indent="0">
+              <a:defRPr sz="2300" b="1">
+                <a:solidFill>
+                  <a:srgbClr val="FFFFFF"/>
+                </a:solidFill>
+                <a:latin typeface="Inter"/>
+              </a:defRPr>
+              <a:lnSpc>
+                <a:spcPct val="112000"/>
+              </a:lnSpc>
+              <a:spcAft>
+                <a:spcPts val="1200"/>
+              </a:spcAft>
+              <a:buNone/>
+            </a:pPr>
+            <a:r>
+              <a:t>Wide</a:t>
+            </a:r>
+          </a:p>
+        </p:txBody>
+      </p:sp>
+      <p:sp>
+        <p:nvSpPr>
+          <p:cNvPr id="5" name="Logo ground / wide"/>
+          <p:cNvSpPr/>
+          <p:nvPr/>
+        </p:nvSpPr>
+        <p:spPr>
+          <a:xfrm>
+            <a:off x="594360" y="2743200"/>
+            <a:ext cx="3383280" cy="2971800"/>
+          </a:xfrm>
+          <a:prstGeom prst="rect">
+            <a:avLst/>
+          </a:prstGeom>
+          <a:solidFill>
+            <a:srgbClr val="082952"/>
+          </a:solidFill>
+          <a:ln>
+            <a:noFill/>
+          </a:ln>
+          <a:effectLst/>
+        </p:spPr>
+        <p:txBody>
+          <a:bodyPr rtlCol="0" anchor="ctr"/>
+          <a:lstStyle/>
+          <a:p>
+            <a:pPr algn="ctr"/>
+          </a:p>
+        </p:txBody>
+      </p:sp>
+      <p:pic>
+        <p:nvPicPr>
+          <p:cNvPr id="6" name="Logo / Wide / White (SVG)" descr="Lugano's Plan B original logo; existing mark, not a new Foundation logo"/>
+          <p:cNvPicPr>
+            <a:picLocks noChangeAspect="1"/>
+          </p:cNvPicPr>
+          <p:nvPr/>
+        </p:nvPicPr>
+        <p:blipFill>
+          <a:blip r:embed="rId2">
+            <a:ext uri="{96DAC541-7B7A-43D3-8B79-37D633B846F1}">
+              <ns0:svgBlip xmlns:ns0="http://schemas.microsoft.com/office/drawing/2016/SVG/main" r:embed="rId3"/>
+            </a:ext>
+          </a:blip>
+          <a:stretch>
+            <a:fillRect/>
+          </a:stretch>
+        </p:blipFill>
+        <p:spPr>
+          <a:xfrm>
+            <a:off x="822960" y="3919134"/>
+            <a:ext cx="2926080" cy="619932"/>
+          </a:xfrm>
+          <a:prstGeom prst="rect">
+            <a:avLst/>
+          </a:prstGeom>
+        </p:spPr>
+      </p:pic>
+      <p:sp>
+        <p:nvSpPr>
+          <p:cNvPr id="7" name="Square"/>
+          <p:cNvSpPr txBox="1"/>
+          <p:nvPr/>
+        </p:nvSpPr>
+        <p:spPr>
+          <a:xfrm>
+            <a:off x="4389120" y="2194560"/>
+            <a:ext cx="3383280" cy="411480"/>
+          </a:xfrm>
+          <a:prstGeom prst="rect">
+            <a:avLst/>
+          </a:prstGeom>
+          <a:noFill/>
+        </p:spPr>
+        <p:txBody>
+          <a:bodyPr wrap="square" lIns="0" rIns="0" tIns="0" bIns="0">
+            <a:spAutoFit/>
+          </a:bodyPr>
+          <a:lstStyle/>
+          <a:p>
+            <a:pPr algn="l" marL="0" indent="0">
+              <a:defRPr sz="2300" b="1">
+                <a:solidFill>
+                  <a:srgbClr val="FFFFFF"/>
+                </a:solidFill>
+                <a:latin typeface="Inter"/>
+              </a:defRPr>
+              <a:lnSpc>
+                <a:spcPct val="112000"/>
+              </a:lnSpc>
+              <a:spcAft>
+                <a:spcPts val="1200"/>
+              </a:spcAft>
+              <a:buNone/>
+            </a:pPr>
+            <a:r>
+              <a:t>Square</a:t>
+            </a:r>
+          </a:p>
+        </p:txBody>
+      </p:sp>
+      <p:sp>
+        <p:nvSpPr>
+          <p:cNvPr id="8" name="Logo ground / square"/>
+          <p:cNvSpPr/>
+          <p:nvPr/>
+        </p:nvSpPr>
+        <p:spPr>
+          <a:xfrm>
+            <a:off x="4389120" y="2743200"/>
+            <a:ext cx="3383280" cy="2971800"/>
+          </a:xfrm>
+          <a:prstGeom prst="rect">
+            <a:avLst/>
+          </a:prstGeom>
+          <a:solidFill>
+            <a:srgbClr val="082952"/>
+          </a:solidFill>
+          <a:ln>
+            <a:noFill/>
+          </a:ln>
+          <a:effectLst/>
+        </p:spPr>
+        <p:txBody>
+          <a:bodyPr rtlCol="0" anchor="ctr"/>
+          <a:lstStyle/>
+          <a:p>
+            <a:pPr algn="ctr"/>
+          </a:p>
+        </p:txBody>
+      </p:sp>
+      <p:pic>
+        <p:nvPicPr>
+          <p:cNvPr id="9" name="Logo / Square / White (SVG)" descr="Lugano's Plan B original logo; existing mark, not a new Foundation logo"/>
+          <p:cNvPicPr>
+            <a:picLocks noChangeAspect="1"/>
+          </p:cNvPicPr>
+          <p:nvPr/>
+        </p:nvPicPr>
+        <p:blipFill>
+          <a:blip r:embed="rId4">
+            <a:ext uri="{96DAC541-7B7A-43D3-8B79-37D633B846F1}">
+              <ns0:svgBlip xmlns:ns0="http://schemas.microsoft.com/office/drawing/2016/SVG/main" r:embed="rId5"/>
+            </a:ext>
+          </a:blip>
+          <a:stretch>
+            <a:fillRect/>
+          </a:stretch>
+        </p:blipFill>
+        <p:spPr>
+          <a:xfrm>
+            <a:off x="4617720" y="3713523"/>
+            <a:ext cx="2926080" cy="1031154"/>
+          </a:xfrm>
+          <a:prstGeom prst="rect">
+            <a:avLst/>
+          </a:prstGeom>
+        </p:spPr>
+      </p:pic>
+      <p:sp>
+        <p:nvSpPr>
+          <p:cNvPr id="10" name="Tall"/>
+          <p:cNvSpPr txBox="1"/>
+          <p:nvPr/>
+        </p:nvSpPr>
+        <p:spPr>
+          <a:xfrm>
+            <a:off x="8183880" y="2194560"/>
+            <a:ext cx="3383280" cy="411480"/>
+          </a:xfrm>
+          <a:prstGeom prst="rect">
+            <a:avLst/>
+          </a:prstGeom>
+          <a:noFill/>
+        </p:spPr>
+        <p:txBody>
+          <a:bodyPr wrap="square" lIns="0" rIns="0" tIns="0" bIns="0">
+            <a:spAutoFit/>
+          </a:bodyPr>
+          <a:lstStyle/>
+          <a:p>
+            <a:pPr algn="l" marL="0" indent="0">
+              <a:defRPr sz="2300" b="1">
+                <a:solidFill>
+                  <a:srgbClr val="FFFFFF"/>
+                </a:solidFill>
+                <a:latin typeface="Inter"/>
+              </a:defRPr>
+              <a:lnSpc>
+                <a:spcPct val="112000"/>
+              </a:lnSpc>
+              <a:spcAft>
+                <a:spcPts val="1200"/>
+              </a:spcAft>
+              <a:buNone/>
+            </a:pPr>
+            <a:r>
+              <a:t>Tall</a:t>
+            </a:r>
+          </a:p>
+        </p:txBody>
+      </p:sp>
+      <p:sp>
+        <p:nvSpPr>
+          <p:cNvPr id="11" name="Logo ground / tall"/>
+          <p:cNvSpPr/>
+          <p:nvPr/>
+        </p:nvSpPr>
+        <p:spPr>
+          <a:xfrm>
+            <a:off x="8183880" y="2743200"/>
+            <a:ext cx="3383280" cy="2971800"/>
+          </a:xfrm>
+          <a:prstGeom prst="rect">
+            <a:avLst/>
+          </a:prstGeom>
+          <a:solidFill>
+            <a:srgbClr val="082952"/>
+          </a:solidFill>
+          <a:ln>
+            <a:noFill/>
+          </a:ln>
+          <a:effectLst/>
+        </p:spPr>
+        <p:txBody>
+          <a:bodyPr rtlCol="0" anchor="ctr"/>
+          <a:lstStyle/>
+          <a:p>
+            <a:pPr algn="ctr"/>
+          </a:p>
+        </p:txBody>
+      </p:sp>
+      <p:pic>
+        <p:nvPicPr>
+          <p:cNvPr id="12" name="Logo / Tall / White (SVG)" descr="Lugano's Plan B original logo; existing mark, not a new Foundation logo"/>
+          <p:cNvPicPr>
+            <a:picLocks noChangeAspect="1"/>
+          </p:cNvPicPr>
+          <p:nvPr/>
+        </p:nvPicPr>
+        <p:blipFill>
+          <a:blip r:embed="rId6">
+            <a:ext uri="{96DAC541-7B7A-43D3-8B79-37D633B846F1}">
+              <ns0:svgBlip xmlns:ns0="http://schemas.microsoft.com/office/drawing/2016/SVG/main" r:embed="rId7"/>
+            </a:ext>
+          </a:blip>
+          <a:stretch>
+            <a:fillRect/>
+          </a:stretch>
+        </p:blipFill>
+        <p:spPr>
+          <a:xfrm>
+            <a:off x="9121140" y="2971800"/>
+            <a:ext cx="1508760" cy="2514600"/>
+          </a:xfrm>
+          <a:prstGeom prst="rect">
+            <a:avLst/>
+          </a:prstGeom>
+        </p:spPr>
+      </p:pic>
     </p:spTree>
   </p:cSld>
   <p:clrMapOvr>
@@ -6577,7 +7249,7 @@
       <p:grpSpPr/>
       <p:sp>
         <p:nvSpPr>
-          <p:cNvPr id="5" name="Placeholder 0"/>
+          <p:cNvPr id="3" name="Placeholder 0"/>
           <p:cNvSpPr txBox="1"/>
           <p:nvPr>
             <p:ph type="title" idx="0"/>
@@ -6622,7 +7294,7 @@
       </p:sp>
       <p:sp>
         <p:nvSpPr>
-          <p:cNvPr id="6" name="Placeholder 1"/>
+          <p:cNvPr id="4" name="Placeholder 1"/>
           <p:cNvSpPr txBox="1"/>
           <p:nvPr>
             <p:ph type="body" idx="1"/>
@@ -6693,7 +7365,7 @@
       <p:grpSpPr/>
       <p:sp>
         <p:nvSpPr>
-          <p:cNvPr id="5" name="Placeholder 0"/>
+          <p:cNvPr id="3" name="Placeholder 0"/>
           <p:cNvSpPr txBox="1"/>
           <p:nvPr>
             <p:ph type="title" idx="0"/>
@@ -6738,7 +7410,7 @@
       </p:sp>
       <p:sp>
         <p:nvSpPr>
-          <p:cNvPr id="6" name="Placeholder 1"/>
+          <p:cNvPr id="4" name="Placeholder 1"/>
           <p:cNvSpPr txBox="1"/>
           <p:nvPr>
             <p:ph type="body" idx="1"/>
@@ -6783,7 +7455,7 @@
       </p:sp>
       <p:sp>
         <p:nvSpPr>
-          <p:cNvPr id="7" name="Placeholder 2"/>
+          <p:cNvPr id="5" name="Placeholder 2"/>
           <p:cNvSpPr txBox="1"/>
           <p:nvPr>
             <p:ph type="body" idx="2"/>
@@ -6894,7 +7566,7 @@
       <p:grpSpPr/>
       <p:sp>
         <p:nvSpPr>
-          <p:cNvPr id="5" name="Placeholder 0"/>
+          <p:cNvPr id="3" name="Placeholder 0"/>
           <p:cNvSpPr txBox="1"/>
           <p:nvPr>
             <p:ph type="title" idx="0"/>
@@ -6939,7 +7611,7 @@
       </p:sp>
       <p:sp>
         <p:nvSpPr>
-          <p:cNvPr id="6" name="Placeholder 1"/>
+          <p:cNvPr id="4" name="Placeholder 1"/>
           <p:cNvSpPr txBox="1"/>
           <p:nvPr>
             <p:ph type="body" idx="1"/>
@@ -6984,7 +7656,7 @@
       </p:sp>
       <p:sp>
         <p:nvSpPr>
-          <p:cNvPr id="7" name="Placeholder 2"/>
+          <p:cNvPr id="5" name="Placeholder 2"/>
           <p:cNvSpPr txBox="1"/>
           <p:nvPr>
             <p:ph type="body" idx="2"/>
@@ -7029,7 +7701,7 @@
       </p:sp>
       <p:sp>
         <p:nvSpPr>
-          <p:cNvPr id="8" name="Placeholder 3"/>
+          <p:cNvPr id="6" name="Placeholder 3"/>
           <p:cNvSpPr txBox="1"/>
           <p:nvPr>
             <p:ph type="body" idx="3"/>
@@ -7074,7 +7746,7 @@
       </p:sp>
       <p:sp>
         <p:nvSpPr>
-          <p:cNvPr id="9" name="Placeholder 4"/>
+          <p:cNvPr id="7" name="Placeholder 4"/>
           <p:cNvSpPr txBox="1"/>
           <p:nvPr>
             <p:ph type="body" idx="4"/>
@@ -7145,7 +7817,7 @@
       <p:grpSpPr/>
       <p:sp>
         <p:nvSpPr>
-          <p:cNvPr id="5" name="Placeholder 0"/>
+          <p:cNvPr id="3" name="Placeholder 0"/>
           <p:cNvSpPr txBox="1"/>
           <p:nvPr>
             <p:ph type="title" idx="0"/>
@@ -7190,7 +7862,7 @@
       </p:sp>
       <p:sp>
         <p:nvSpPr>
-          <p:cNvPr id="8" name="Placeholder 1"/>
+          <p:cNvPr id="6" name="Placeholder 1"/>
           <p:cNvSpPr txBox="1"/>
           <p:nvPr>
             <p:ph type="pic" idx="1"/>
@@ -7235,7 +7907,7 @@
       </p:sp>
       <p:sp>
         <p:nvSpPr>
-          <p:cNvPr id="9" name="Placeholder 2"/>
+          <p:cNvPr id="7" name="Placeholder 2"/>
           <p:cNvSpPr txBox="1"/>
           <p:nvPr>
             <p:ph type="body" idx="2"/>
@@ -7280,7 +7952,7 @@
       </p:sp>
       <p:sp>
         <p:nvSpPr>
-          <p:cNvPr id="10" name="Placeholder 3"/>
+          <p:cNvPr id="8" name="Placeholder 3"/>
           <p:cNvSpPr txBox="1"/>
           <p:nvPr>
             <p:ph type="body" idx="3"/>
@@ -7325,7 +7997,7 @@
       </p:sp>
       <p:sp>
         <p:nvSpPr>
-          <p:cNvPr id="11" name="Placeholder 4"/>
+          <p:cNvPr id="9" name="Placeholder 4"/>
           <p:cNvSpPr txBox="1"/>
           <p:nvPr>
             <p:ph type="body" idx="4"/>
@@ -7396,7 +8068,7 @@
       <p:grpSpPr/>
       <p:sp>
         <p:nvSpPr>
-          <p:cNvPr id="5" name="Placeholder 0"/>
+          <p:cNvPr id="3" name="Placeholder 0"/>
           <p:cNvSpPr txBox="1"/>
           <p:nvPr>
             <p:ph type="title" idx="0"/>
@@ -7441,7 +8113,7 @@
       </p:sp>
       <p:sp>
         <p:nvSpPr>
-          <p:cNvPr id="6" name="Placeholder 1"/>
+          <p:cNvPr id="4" name="Placeholder 1"/>
           <p:cNvSpPr txBox="1"/>
           <p:nvPr>
             <p:ph type="body" idx="1"/>
@@ -7486,7 +8158,7 @@
       </p:sp>
       <p:sp>
         <p:nvSpPr>
-          <p:cNvPr id="8" name="Placeholder 3"/>
+          <p:cNvPr id="6" name="Placeholder 3"/>
           <p:cNvSpPr txBox="1"/>
           <p:nvPr>
             <p:ph type="body" idx="3"/>
@@ -7531,7 +8203,7 @@
       </p:sp>
       <p:sp>
         <p:nvSpPr>
-          <p:cNvPr id="9" name="Placeholder 4"/>
+          <p:cNvPr id="7" name="Placeholder 4"/>
           <p:cNvSpPr txBox="1"/>
           <p:nvPr>
             <p:ph type="body" idx="4"/>
@@ -7576,7 +8248,7 @@
       </p:sp>
       <p:sp>
         <p:nvSpPr>
-          <p:cNvPr id="10" name="Placeholder 5"/>
+          <p:cNvPr id="8" name="Placeholder 5"/>
           <p:cNvSpPr txBox="1"/>
           <p:nvPr>
             <p:ph type="body" idx="5"/>
@@ -7621,7 +8293,7 @@
       </p:sp>
       <p:graphicFrame>
         <p:nvGraphicFramePr>
-          <p:cNvPr id="11" name="Chart 10"/>
+          <p:cNvPr id="9" name="Chart 8"/>
           <p:cNvGraphicFramePr>
             <a:graphicFrameLocks noGrp="1"/>
           </p:cNvGraphicFramePr>
@@ -7665,7 +8337,7 @@
       <p:grpSpPr/>
       <p:sp>
         <p:nvSpPr>
-          <p:cNvPr id="5" name="Placeholder 0"/>
+          <p:cNvPr id="3" name="Placeholder 0"/>
           <p:cNvSpPr txBox="1"/>
           <p:nvPr>
             <p:ph type="title" idx="0"/>
@@ -7710,7 +8382,7 @@
       </p:sp>
       <p:sp>
         <p:nvSpPr>
-          <p:cNvPr id="6" name="Placeholder 1"/>
+          <p:cNvPr id="4" name="Placeholder 1"/>
           <p:cNvSpPr txBox="1"/>
           <p:nvPr>
             <p:ph type="body" idx="1"/>
@@ -7755,7 +8427,7 @@
       </p:sp>
       <p:sp>
         <p:nvSpPr>
-          <p:cNvPr id="8" name="Placeholder 3"/>
+          <p:cNvPr id="6" name="Placeholder 3"/>
           <p:cNvSpPr txBox="1"/>
           <p:nvPr>
             <p:ph type="body" idx="3"/>
@@ -7800,7 +8472,7 @@
       </p:sp>
       <p:graphicFrame>
         <p:nvGraphicFramePr>
-          <p:cNvPr id="9" name="Table 8"/>
+          <p:cNvPr id="7" name="Table 6"/>
           <p:cNvGraphicFramePr>
             <a:graphicFrameLocks noGrp="1"/>
           </p:cNvGraphicFramePr>
@@ -8149,7 +8821,7 @@
       <p:grpSpPr/>
       <p:sp>
         <p:nvSpPr>
-          <p:cNvPr id="5" name="Placeholder 0"/>
+          <p:cNvPr id="3" name="Placeholder 0"/>
           <p:cNvSpPr txBox="1"/>
           <p:nvPr>
             <p:ph type="title" idx="0"/>
@@ -8214,7 +8886,7 @@
       </p:sp>
       <p:sp>
         <p:nvSpPr>
-          <p:cNvPr id="6" name="Placeholder 1"/>
+          <p:cNvPr id="4" name="Placeholder 1"/>
           <p:cNvSpPr txBox="1"/>
           <p:nvPr>
             <p:ph type="body" idx="1"/>
@@ -8305,7 +8977,7 @@
       <p:grpSpPr/>
       <p:sp>
         <p:nvSpPr>
-          <p:cNvPr id="5" name="Placeholder 0"/>
+          <p:cNvPr id="3" name="Placeholder 0"/>
           <p:cNvSpPr txBox="1"/>
           <p:nvPr>
             <p:ph type="title" idx="0"/>
@@ -8350,7 +9022,7 @@
       </p:sp>
       <p:sp>
         <p:nvSpPr>
-          <p:cNvPr id="6" name="Placeholder 1"/>
+          <p:cNvPr id="4" name="Placeholder 1"/>
           <p:cNvSpPr txBox="1"/>
           <p:nvPr>
             <p:ph type="body" idx="1"/>
@@ -8395,7 +9067,7 @@
       </p:sp>
       <p:sp>
         <p:nvSpPr>
-          <p:cNvPr id="7" name="Placeholder 2"/>
+          <p:cNvPr id="5" name="Placeholder 2"/>
           <p:cNvSpPr txBox="1"/>
           <p:nvPr>
             <p:ph type="body" idx="2"/>
@@ -8460,7 +9132,7 @@
       </p:sp>
       <p:sp>
         <p:nvSpPr>
-          <p:cNvPr id="8" name="Placeholder 3"/>
+          <p:cNvPr id="6" name="Placeholder 3"/>
           <p:cNvSpPr txBox="1"/>
           <p:nvPr>
             <p:ph type="body" idx="3"/>
@@ -8505,7 +9177,7 @@
       </p:sp>
       <p:sp>
         <p:nvSpPr>
-          <p:cNvPr id="9" name="Placeholder 4"/>
+          <p:cNvPr id="7" name="Placeholder 4"/>
           <p:cNvSpPr txBox="1"/>
           <p:nvPr>
             <p:ph type="body" idx="4"/>
@@ -8570,7 +9242,7 @@
       </p:sp>
       <p:sp>
         <p:nvSpPr>
-          <p:cNvPr id="10" name="Placeholder 5"/>
+          <p:cNvPr id="8" name="Placeholder 5"/>
           <p:cNvSpPr txBox="1"/>
           <p:nvPr>
             <p:ph type="body" idx="5"/>
@@ -8615,7 +9287,7 @@
       </p:sp>
       <p:sp>
         <p:nvSpPr>
-          <p:cNvPr id="11" name="Placeholder 6"/>
+          <p:cNvPr id="9" name="Placeholder 6"/>
           <p:cNvSpPr txBox="1"/>
           <p:nvPr>
             <p:ph type="body" idx="6"/>
@@ -8680,7 +9352,7 @@
       </p:sp>
       <p:sp>
         <p:nvSpPr>
-          <p:cNvPr id="12" name="Placeholder 7"/>
+          <p:cNvPr id="10" name="Placeholder 7"/>
           <p:cNvSpPr txBox="1"/>
           <p:nvPr>
             <p:ph type="body" idx="7"/>

</xml_diff>